<commit_message>
docs: them anh thao tac + huong dan gui minh chung qua Google Drive vao slide diem danh bo sung
Co-Authored-By: Claude Opus 5.5 <noreply@anthropic.com>
</commit_message>
<xml_diff>
--- a/docs/huong-dan-diem-danh-bo-sung-ho-tro.pptx
+++ b/docs/huong-dan-diem-danh-bo-sung-ho-tro.pptx
@@ -12,9 +12,11 @@
     <p:sldId id="260" r:id="rId6"/>
     <p:sldId id="261" r:id="rId7"/>
     <p:sldId id="262" r:id="rId8"/>
+    <p:sldId id="263" r:id="rId9"/>
+    <p:sldId id="264" r:id="rId10"/>
   </p:sldIdLst>
   <p:notesMasterIdLst>
-    <p:notesMasterId r:id="rId9"/>
+    <p:notesMasterId r:id="rId11"/>
   </p:notesMasterIdLst>
   <p:sldSz cx="9144000" cy="5143500"/>
   <p:notesSz cx="5143500" cy="9144000"/>
@@ -113,27 +115,29 @@
   <p:extLst>
     <p:ext uri="{521415D9-36F7-43E2-AB2F-B90AF26B5E84}">
       <p14:sectionLst xmlns:p14="http://schemas.microsoft.com/office/powerpoint/2010/main">
-        <p14:section name="Mở đầu" id="{6752e660-a40d-c182-cf2d-1d6594b84f03}">
+        <p14:section name="Mở đầu" id="{ed7c5113-f544-c19b-a1f6-9ce726f65cb6}">
           <p14:sldIdLst>
             <p14:sldId id="256"/>
           </p14:sldIdLst>
         </p14:section>
-        <p14:section name="Quy tắc" id="{68414f41-b413-9158-ea92-9070330f5c90}">
+        <p14:section name="Quy tắc" id="{69a643b2-d4db-e242-3c8a-061b4c48c65a}">
           <p14:sldIdLst>
             <p14:sldId id="257"/>
             <p14:sldId id="258"/>
+            <p14:sldId id="259"/>
           </p14:sldIdLst>
         </p14:section>
-        <p14:section name="Thao tác" id="{74320cd1-b448-9b8f-fa69-47af8f4baf20}">
+        <p14:section name="Thao tác" id="{4251b13b-1525-fb8d-e9c0-226b8f623410}">
           <p14:sldIdLst>
-            <p14:sldId id="259"/>
             <p14:sldId id="260"/>
             <p14:sldId id="261"/>
+            <p14:sldId id="262"/>
+            <p14:sldId id="263"/>
           </p14:sldIdLst>
         </p14:section>
-        <p14:section name="Lưu ý" id="{19d37c9d-3149-a0c8-b01b-a21bcb80818e}">
+        <p14:section name="Lưu ý" id="{1911f10e-5ef2-1cb6-a5c1-fef3081fc4b8}">
           <p14:sldIdLst>
-            <p14:sldId id="262"/>
+            <p14:sldId id="264"/>
           </p14:sldIdLst>
         </p14:section>
       </p14:sectionLst>
@@ -540,7 +544,7 @@
           <a:p>
             <a:r>
               <a:rPr lang="en-US" dirty="0"/>
-              <a:t/>
+              <a:t>Ảnh minh họa dùng dữ liệu giả (học viên Nguyễn Văn An, lớp Z-MINH-HOA).</a:t>
             </a:r>
             <a:endParaRPr lang="en-US" dirty="0"/>
           </a:p>
@@ -1092,6 +1096,182 @@
             <a:fld id="{F7021451-1387-4CA6-816F-3879F97B5CBC}" type="slidenum">
               <a:rPr lang="en-US"/>
               <a:t>7</a:t>
+            </a:fld>
+            <a:endParaRPr lang="en-US"/>
+          </a:p>
+        </p:txBody>
+      </p:sp>
+    </p:spTree>
+    <p:extLst>
+      <p:ext uri="{BB962C8B-B14F-4D97-AF65-F5344CB8AC3E}">
+        <p14:creationId xmlns:p14="http://schemas.microsoft.com/office/powerpoint/2010/main" val="1024086991"/>
+      </p:ext>
+    </p:extLst>
+  </p:cSld>
+  <p:clrMapOvr>
+    <a:masterClrMapping/>
+  </p:clrMapOvr>
+</p:notes>
+</file>
+
+<file path=ppt/notesSlides/notesSlide8.xml><?xml version="1.0" encoding="utf-8"?>
+<p:notes xmlns:a="http://schemas.openxmlformats.org/drawingml/2006/main" xmlns:r="http://schemas.openxmlformats.org/officeDocument/2006/relationships" xmlns:p="http://schemas.openxmlformats.org/presentationml/2006/main">
+  <p:cSld>
+    <p:spTree>
+      <p:nvGrpSpPr>
+        <p:cNvPr id="1" name=""/>
+        <p:cNvGrpSpPr/>
+        <p:nvPr/>
+      </p:nvGrpSpPr>
+      <p:grpSpPr>
+        <a:xfrm>
+          <a:off x="0" y="0"/>
+          <a:ext cx="0" cy="0"/>
+          <a:chOff x="0" y="0"/>
+          <a:chExt cx="0" cy="0"/>
+        </a:xfrm>
+      </p:grpSpPr>
+      <p:sp>
+        <p:nvSpPr>
+          <p:cNvPr id="2" name="Slide Image Placeholder 1"/>
+          <p:cNvSpPr>
+            <a:spLocks noGrp="1" noRot="1" noChangeAspect="1"/>
+          </p:cNvSpPr>
+          <p:nvPr>
+            <p:ph type="sldImg"/>
+          </p:nvPr>
+        </p:nvSpPr>
+        <p:spPr/>
+      </p:sp>
+      <p:sp>
+        <p:nvSpPr>
+          <p:cNvPr id="3" name="Notes Placeholder 2"/>
+          <p:cNvSpPr>
+            <a:spLocks noGrp="1"/>
+          </p:cNvSpPr>
+          <p:nvPr>
+            <p:ph type="body" idx="1"/>
+          </p:nvPr>
+        </p:nvSpPr>
+        <p:spPr/>
+        <p:txBody>
+          <a:bodyPr/>
+          <a:lstStyle/>
+          <a:p>
+            <a:r>
+              <a:rPr lang="en-US" dirty="0"/>
+              <a:t/>
+            </a:r>
+            <a:endParaRPr lang="en-US" dirty="0"/>
+          </a:p>
+        </p:txBody>
+      </p:sp>
+      <p:sp>
+        <p:nvSpPr>
+          <p:cNvPr id="4" name="Slide Number Placeholder 3"/>
+          <p:cNvSpPr>
+            <a:spLocks noGrp="1"/>
+          </p:cNvSpPr>
+          <p:nvPr>
+            <p:ph type="sldNum" sz="quarter" idx="10"/>
+          </p:nvPr>
+        </p:nvSpPr>
+        <p:spPr/>
+        <p:txBody>
+          <a:bodyPr/>
+          <a:lstStyle/>
+          <a:p>
+            <a:fld id="{F7021451-1387-4CA6-816F-3879F97B5CBC}" type="slidenum">
+              <a:rPr lang="en-US"/>
+              <a:t>8</a:t>
+            </a:fld>
+            <a:endParaRPr lang="en-US"/>
+          </a:p>
+        </p:txBody>
+      </p:sp>
+    </p:spTree>
+    <p:extLst>
+      <p:ext uri="{BB962C8B-B14F-4D97-AF65-F5344CB8AC3E}">
+        <p14:creationId xmlns:p14="http://schemas.microsoft.com/office/powerpoint/2010/main" val="1024086991"/>
+      </p:ext>
+    </p:extLst>
+  </p:cSld>
+  <p:clrMapOvr>
+    <a:masterClrMapping/>
+  </p:clrMapOvr>
+</p:notes>
+</file>
+
+<file path=ppt/notesSlides/notesSlide9.xml><?xml version="1.0" encoding="utf-8"?>
+<p:notes xmlns:a="http://schemas.openxmlformats.org/drawingml/2006/main" xmlns:r="http://schemas.openxmlformats.org/officeDocument/2006/relationships" xmlns:p="http://schemas.openxmlformats.org/presentationml/2006/main">
+  <p:cSld>
+    <p:spTree>
+      <p:nvGrpSpPr>
+        <p:cNvPr id="1" name=""/>
+        <p:cNvGrpSpPr/>
+        <p:nvPr/>
+      </p:nvGrpSpPr>
+      <p:grpSpPr>
+        <a:xfrm>
+          <a:off x="0" y="0"/>
+          <a:ext cx="0" cy="0"/>
+          <a:chOff x="0" y="0"/>
+          <a:chExt cx="0" cy="0"/>
+        </a:xfrm>
+      </p:grpSpPr>
+      <p:sp>
+        <p:nvSpPr>
+          <p:cNvPr id="2" name="Slide Image Placeholder 1"/>
+          <p:cNvSpPr>
+            <a:spLocks noGrp="1" noRot="1" noChangeAspect="1"/>
+          </p:cNvSpPr>
+          <p:nvPr>
+            <p:ph type="sldImg"/>
+          </p:nvPr>
+        </p:nvSpPr>
+        <p:spPr/>
+      </p:sp>
+      <p:sp>
+        <p:nvSpPr>
+          <p:cNvPr id="3" name="Notes Placeholder 2"/>
+          <p:cNvSpPr>
+            <a:spLocks noGrp="1"/>
+          </p:cNvSpPr>
+          <p:nvPr>
+            <p:ph type="body" idx="1"/>
+          </p:nvPr>
+        </p:nvSpPr>
+        <p:spPr/>
+        <p:txBody>
+          <a:bodyPr/>
+          <a:lstStyle/>
+          <a:p>
+            <a:r>
+              <a:rPr lang="en-US" dirty="0"/>
+              <a:t/>
+            </a:r>
+            <a:endParaRPr lang="en-US" dirty="0"/>
+          </a:p>
+        </p:txBody>
+      </p:sp>
+      <p:sp>
+        <p:nvSpPr>
+          <p:cNvPr id="4" name="Slide Number Placeholder 3"/>
+          <p:cNvSpPr>
+            <a:spLocks noGrp="1"/>
+          </p:cNvSpPr>
+          <p:nvPr>
+            <p:ph type="sldNum" sz="quarter" idx="10"/>
+          </p:nvPr>
+        </p:nvSpPr>
+        <p:spPr/>
+        <p:txBody>
+          <a:bodyPr/>
+          <a:lstStyle/>
+          <a:p>
+            <a:fld id="{F7021451-1387-4CA6-816F-3879F97B5CBC}" type="slidenum">
+              <a:rPr lang="en-US"/>
+              <a:t>9</a:t>
             </a:fld>
             <a:endParaRPr lang="en-US"/>
           </a:p>
@@ -3721,7 +3901,7 @@
                   <a:schemeClr val="tx2"/>
                 </a:solidFill>
               </a:rPr>
-              <a:t>Tra cứu học viên – menu Tình hình đi học</a:t>
+              <a:t>Kiểm tra minh chứng trước khi ghi</a:t>
             </a:r>
             <a:endParaRPr lang="en-US" sz="2800" dirty="0"/>
           </a:p>
@@ -3729,17 +3909,249 @@
       </p:sp>
       <p:sp>
         <p:nvSpPr>
-          <p:cNvPr id="3" name="So 1"/>
+          <p:cNvPr id="3" name="Minh chứng hợp lệ"/>
           <p:cNvSpPr/>
           <p:nvPr/>
         </p:nvSpPr>
         <p:spPr>
           <a:xfrm>
-            <a:off x="457200" y="1188720"/>
-            <a:ext cx="365760" cy="365760"/>
-          </a:xfrm>
-          <a:prstGeom prst="ellipse">
-            <a:avLst/>
+            <a:off x="457200" y="1097280"/>
+            <a:ext cx="3977640" cy="2331720"/>
+          </a:xfrm>
+          <a:prstGeom prst="roundRect">
+            <a:avLst>
+              <a:gd name="adj" fmla="val 3137"/>
+            </a:avLst>
+          </a:prstGeom>
+          <a:solidFill>
+            <a:schemeClr val="bg2"/>
+          </a:solidFill>
+          <a:ln/>
+        </p:spPr>
+      </p:sp>
+      <p:sp>
+        <p:nvSpPr>
+          <p:cNvPr id="4" name="Text 2"/>
+          <p:cNvSpPr txBox="1"/>
+          <p:nvPr/>
+        </p:nvSpPr>
+        <p:spPr>
+          <a:xfrm>
+            <a:off x="594360" y="1207008"/>
+            <a:ext cx="3703320" cy="2112264"/>
+          </a:xfrm>
+          <a:prstGeom prst="rect">
+            <a:avLst/>
+          </a:prstGeom>
+          <a:noFill/>
+          <a:ln/>
+        </p:spPr>
+        <p:txBody>
+          <a:bodyPr wrap="square" lIns="0" tIns="0" rIns="0" bIns="0" rtlCol="0" anchor="t"/>
+          <a:lstStyle/>
+          <a:p>
+            <a:pPr indent="0" marL="0">
+              <a:spcAft>
+                <a:spcPts val="600"/>
+              </a:spcAft>
+              <a:buNone/>
+            </a:pPr>
+            <a:r>
+              <a:rPr lang="en-US" sz="1600" b="1" dirty="0">
+                <a:solidFill>
+                  <a:schemeClr val="accent1"/>
+                </a:solidFill>
+              </a:rPr>
+              <a:t>Minh chứng hợp lệ</a:t>
+            </a:r>
+            <a:endParaRPr lang="en-US" sz="1600" dirty="0"/>
+          </a:p>
+          <a:p>
+            <a:pPr marL="177800" indent="-177800">
+              <a:spcAft>
+                <a:spcPts val="400"/>
+              </a:spcAft>
+              <a:buSzPct val="100000"/>
+              <a:buChar char="•"/>
+            </a:pPr>
+            <a:r>
+              <a:rPr lang="en-US" sz="1400" dirty="0">
+                <a:solidFill>
+                  <a:schemeClr val="tx1"/>
+                </a:solidFill>
+              </a:rPr>
+              <a:t>Ảnh thấy rõ tên học viên + ngày giờ khớp buổi</a:t>
+            </a:r>
+            <a:endParaRPr lang="en-US" sz="1600" dirty="0"/>
+          </a:p>
+          <a:p>
+            <a:pPr marL="177800" indent="-177800">
+              <a:spcAft>
+                <a:spcPts val="400"/>
+              </a:spcAft>
+              <a:buSzPct val="100000"/>
+              <a:buChar char="•"/>
+            </a:pPr>
+            <a:r>
+              <a:rPr lang="en-US" sz="1400" dirty="0">
+                <a:solidFill>
+                  <a:schemeClr val="tx1"/>
+                </a:solidFill>
+              </a:rPr>
+              <a:t>Danh sách ký tên, hoặc xác nhận của giảng viên</a:t>
+            </a:r>
+            <a:endParaRPr lang="en-US" sz="1600" dirty="0"/>
+          </a:p>
+          <a:p>
+            <a:pPr marL="177800" indent="-177800">
+              <a:spcAft>
+                <a:spcPts val="400"/>
+              </a:spcAft>
+              <a:buSzPct val="100000"/>
+              <a:buChar char="•"/>
+            </a:pPr>
+            <a:r>
+              <a:rPr lang="en-US" sz="1400" dirty="0">
+                <a:solidFill>
+                  <a:schemeClr val="tx1"/>
+                </a:solidFill>
+              </a:rPr>
+              <a:t>Xin “Vắng có phép”: có giấy tờ lý do</a:t>
+            </a:r>
+            <a:endParaRPr lang="en-US" sz="1600" dirty="0"/>
+          </a:p>
+        </p:txBody>
+      </p:sp>
+      <p:sp>
+        <p:nvSpPr>
+          <p:cNvPr id="5" name="Link Google Drive từ mục Hỗ trợ"/>
+          <p:cNvSpPr/>
+          <p:nvPr/>
+        </p:nvSpPr>
+        <p:spPr>
+          <a:xfrm>
+            <a:off x="4709160" y="1097280"/>
+            <a:ext cx="3977640" cy="2331720"/>
+          </a:xfrm>
+          <a:prstGeom prst="roundRect">
+            <a:avLst>
+              <a:gd name="adj" fmla="val 3137"/>
+            </a:avLst>
+          </a:prstGeom>
+          <a:solidFill>
+            <a:schemeClr val="bg2"/>
+          </a:solidFill>
+          <a:ln/>
+        </p:spPr>
+      </p:sp>
+      <p:sp>
+        <p:nvSpPr>
+          <p:cNvPr id="6" name="Text 4"/>
+          <p:cNvSpPr txBox="1"/>
+          <p:nvPr/>
+        </p:nvSpPr>
+        <p:spPr>
+          <a:xfrm>
+            <a:off x="4846320" y="1207008"/>
+            <a:ext cx="3703320" cy="2112264"/>
+          </a:xfrm>
+          <a:prstGeom prst="rect">
+            <a:avLst/>
+          </a:prstGeom>
+          <a:noFill/>
+          <a:ln/>
+        </p:spPr>
+        <p:txBody>
+          <a:bodyPr wrap="square" lIns="0" tIns="0" rIns="0" bIns="0" rtlCol="0" anchor="t"/>
+          <a:lstStyle/>
+          <a:p>
+            <a:pPr indent="0" marL="0">
+              <a:spcAft>
+                <a:spcPts val="600"/>
+              </a:spcAft>
+              <a:buNone/>
+            </a:pPr>
+            <a:r>
+              <a:rPr lang="en-US" sz="1600" b="1" dirty="0">
+                <a:solidFill>
+                  <a:schemeClr val="tx2"/>
+                </a:solidFill>
+              </a:rPr>
+              <a:t>Link Google Drive từ mục Hỗ trợ</a:t>
+            </a:r>
+            <a:endParaRPr lang="en-US" sz="1600" dirty="0"/>
+          </a:p>
+          <a:p>
+            <a:pPr marL="177800" indent="-177800">
+              <a:spcAft>
+                <a:spcPts val="400"/>
+              </a:spcAft>
+              <a:buSzPct val="100000"/>
+              <a:buChar char="•"/>
+            </a:pPr>
+            <a:r>
+              <a:rPr lang="en-US" sz="1400" dirty="0">
+                <a:solidFill>
+                  <a:schemeClr val="tx1"/>
+                </a:solidFill>
+              </a:rPr>
+              <a:t>Link hiện dạng chữ – chạm giữ để sao chép rồi mở</a:t>
+            </a:r>
+            <a:endParaRPr lang="en-US" sz="1600" dirty="0"/>
+          </a:p>
+          <a:p>
+            <a:pPr marL="177800" indent="-177800">
+              <a:spcAft>
+                <a:spcPts val="400"/>
+              </a:spcAft>
+              <a:buSzPct val="100000"/>
+              <a:buChar char="•"/>
+            </a:pPr>
+            <a:r>
+              <a:rPr lang="en-US" sz="1400" dirty="0">
+                <a:solidFill>
+                  <a:schemeClr val="tx1"/>
+                </a:solidFill>
+              </a:rPr>
+              <a:t>Báo “cần quyền truy cập” → nhắn học viên đổi sang “Bất kỳ ai có đường liên kết” (không bấm Yêu cầu quyền bằng Gmail cá nhân)</a:t>
+            </a:r>
+            <a:endParaRPr lang="en-US" sz="1600" dirty="0"/>
+          </a:p>
+          <a:p>
+            <a:pPr marL="177800" indent="-177800">
+              <a:spcAft>
+                <a:spcPts val="400"/>
+              </a:spcAft>
+              <a:buSzPct val="100000"/>
+              <a:buChar char="•"/>
+            </a:pPr>
+            <a:r>
+              <a:rPr lang="en-US" sz="1400" dirty="0">
+                <a:solidFill>
+                  <a:schemeClr val="tx1"/>
+                </a:solidFill>
+              </a:rPr>
+              <a:t>Chưa xem được ảnh thì chưa ghi</a:t>
+            </a:r>
+            <a:endParaRPr lang="en-US" sz="1600" dirty="0"/>
+          </a:p>
+        </p:txBody>
+      </p:sp>
+      <p:sp>
+        <p:nvSpPr>
+          <p:cNvPr id="7" name="Goi y ly do"/>
+          <p:cNvSpPr/>
+          <p:nvPr/>
+        </p:nvSpPr>
+        <p:spPr>
+          <a:xfrm>
+            <a:off x="457200" y="3611880"/>
+            <a:ext cx="8229600" cy="685800"/>
+          </a:xfrm>
+          <a:prstGeom prst="roundRect">
+            <a:avLst>
+              <a:gd name="adj" fmla="val 10667"/>
+            </a:avLst>
           </a:prstGeom>
           <a:solidFill>
             <a:schemeClr val="tx2"/>
@@ -3749,856 +4161,48 @@
       </p:sp>
       <p:sp>
         <p:nvSpPr>
-          <p:cNvPr id="4" name="Text 2"/>
-          <p:cNvSpPr txBox="1"/>
-          <p:nvPr/>
-        </p:nvSpPr>
-        <p:spPr>
-          <a:xfrm>
-            <a:off x="457200" y="1188720"/>
-            <a:ext cx="365760" cy="365760"/>
-          </a:xfrm>
-          <a:prstGeom prst="rect">
-            <a:avLst/>
-          </a:prstGeom>
-          <a:noFill/>
-          <a:ln/>
-        </p:spPr>
-        <p:txBody>
-          <a:bodyPr wrap="square" lIns="0" tIns="0" rIns="0" bIns="0" rtlCol="0" anchor="ctr"/>
-          <a:lstStyle/>
-          <a:p>
-            <a:pPr algn="ctr" indent="0" marL="0">
-              <a:buNone/>
-            </a:pPr>
-            <a:r>
-              <a:rPr lang="en-US" sz="1600" b="1" dirty="0">
-                <a:solidFill>
-                  <a:schemeClr val="bg1"/>
-                </a:solidFill>
-              </a:rPr>
-              <a:t>1</a:t>
-            </a:r>
-            <a:endParaRPr lang="en-US" sz="1600" dirty="0"/>
-          </a:p>
-        </p:txBody>
-      </p:sp>
-      <p:sp>
-        <p:nvSpPr>
-          <p:cNvPr id="5" name="Text 3"/>
-          <p:cNvSpPr txBox="1"/>
-          <p:nvPr/>
-        </p:nvSpPr>
-        <p:spPr>
-          <a:xfrm>
-            <a:off x="960120" y="1152144"/>
-            <a:ext cx="3703320" cy="694944"/>
-          </a:xfrm>
-          <a:prstGeom prst="rect">
-            <a:avLst/>
-          </a:prstGeom>
-          <a:noFill/>
-          <a:ln/>
-        </p:spPr>
-        <p:txBody>
-          <a:bodyPr wrap="square" lIns="0" tIns="0" rIns="0" bIns="0" rtlCol="0" anchor="t"/>
-          <a:lstStyle/>
-          <a:p>
-            <a:pPr indent="0" marL="0">
-              <a:buNone/>
-            </a:pPr>
-            <a:r>
-              <a:rPr lang="en-US" sz="1400" dirty="0">
-                <a:solidFill>
-                  <a:schemeClr val="tx1"/>
-                </a:solidFill>
-              </a:rPr>
-              <a:t>Chọn </a:t>
-            </a:r>
-            <a:pPr indent="0" marL="0">
-              <a:buNone/>
-            </a:pPr>
-            <a:r>
-              <a:rPr lang="en-US" sz="1400" b="1" dirty="0">
-                <a:solidFill>
-                  <a:schemeClr val="tx1"/>
-                </a:solidFill>
-              </a:rPr>
-              <a:t>Khóa</a:t>
-            </a:r>
-            <a:pPr indent="0" marL="0">
-              <a:buNone/>
-            </a:pPr>
-            <a:r>
-              <a:rPr lang="en-US" sz="1400" dirty="0">
-                <a:solidFill>
-                  <a:schemeClr val="tx1"/>
-                </a:solidFill>
-              </a:rPr>
-              <a:t> (bắt buộc)</a:t>
-            </a:r>
-            <a:endParaRPr lang="en-US" sz="1400" dirty="0"/>
-          </a:p>
-        </p:txBody>
-      </p:sp>
-      <p:sp>
-        <p:nvSpPr>
-          <p:cNvPr id="6" name="So 2"/>
-          <p:cNvSpPr/>
-          <p:nvPr/>
-        </p:nvSpPr>
-        <p:spPr>
-          <a:xfrm>
-            <a:off x="457200" y="1938528"/>
-            <a:ext cx="365760" cy="365760"/>
-          </a:xfrm>
-          <a:prstGeom prst="ellipse">
-            <a:avLst/>
-          </a:prstGeom>
-          <a:solidFill>
-            <a:schemeClr val="tx2"/>
-          </a:solidFill>
-          <a:ln/>
-        </p:spPr>
-      </p:sp>
-      <p:sp>
-        <p:nvSpPr>
-          <p:cNvPr id="7" name="Text 5"/>
-          <p:cNvSpPr txBox="1"/>
-          <p:nvPr/>
-        </p:nvSpPr>
-        <p:spPr>
-          <a:xfrm>
-            <a:off x="457200" y="1938528"/>
-            <a:ext cx="365760" cy="365760"/>
-          </a:xfrm>
-          <a:prstGeom prst="rect">
-            <a:avLst/>
-          </a:prstGeom>
-          <a:noFill/>
-          <a:ln/>
-        </p:spPr>
-        <p:txBody>
-          <a:bodyPr wrap="square" lIns="0" tIns="0" rIns="0" bIns="0" rtlCol="0" anchor="ctr"/>
-          <a:lstStyle/>
-          <a:p>
-            <a:pPr algn="ctr" indent="0" marL="0">
-              <a:buNone/>
-            </a:pPr>
-            <a:r>
-              <a:rPr lang="en-US" sz="1600" b="1" dirty="0">
-                <a:solidFill>
-                  <a:schemeClr val="bg1"/>
-                </a:solidFill>
-              </a:rPr>
-              <a:t>2</a:t>
-            </a:r>
-            <a:endParaRPr lang="en-US" sz="1600" dirty="0"/>
-          </a:p>
-        </p:txBody>
-      </p:sp>
-      <p:sp>
-        <p:nvSpPr>
           <p:cNvPr id="8" name="Text 6"/>
           <p:cNvSpPr txBox="1"/>
           <p:nvPr/>
         </p:nvSpPr>
         <p:spPr>
           <a:xfrm>
-            <a:off x="960120" y="1901952"/>
-            <a:ext cx="3703320" cy="694944"/>
-          </a:xfrm>
-          <a:prstGeom prst="rect">
-            <a:avLst/>
-          </a:prstGeom>
-          <a:noFill/>
-          <a:ln/>
-        </p:spPr>
-        <p:txBody>
-          <a:bodyPr wrap="square" lIns="0" tIns="0" rIns="0" bIns="0" rtlCol="0" anchor="t"/>
+            <a:off x="640080" y="3611880"/>
+            <a:ext cx="7863840" cy="685800"/>
+          </a:xfrm>
+          <a:prstGeom prst="rect">
+            <a:avLst/>
+          </a:prstGeom>
+          <a:noFill/>
+          <a:ln/>
+        </p:spPr>
+        <p:txBody>
+          <a:bodyPr wrap="square" lIns="0" tIns="0" rIns="0" bIns="0" rtlCol="0" anchor="ctr"/>
           <a:lstStyle/>
           <a:p>
             <a:pPr indent="0" marL="0">
               <a:buNone/>
             </a:pPr>
             <a:r>
+              <a:rPr lang="en-US" sz="1400" b="1" dirty="0">
+                <a:solidFill>
+                  <a:schemeClr val="accent6"/>
+                </a:solidFill>
+              </a:rPr>
+              <a:t>Ghi nguồn vào Lý do: </a:t>
+            </a:r>
+            <a:pPr indent="0" marL="0">
+              <a:buNone/>
+            </a:pPr>
+            <a:r>
               <a:rPr lang="en-US" sz="1400" dirty="0">
                 <a:solidFill>
-                  <a:schemeClr val="tx1"/>
-                </a:solidFill>
-              </a:rPr>
-              <a:t>Gõ </a:t>
-            </a:r>
-            <a:pPr indent="0" marL="0">
-              <a:buNone/>
-            </a:pPr>
-            <a:r>
-              <a:rPr lang="en-US" sz="1400" b="1" dirty="0">
-                <a:solidFill>
-                  <a:schemeClr val="tx1"/>
-                </a:solidFill>
-              </a:rPr>
-              <a:t>họ tên hoặc mã MOET</a:t>
-            </a:r>
-            <a:pPr indent="0" marL="0">
-              <a:buNone/>
-            </a:pPr>
-            <a:r>
-              <a:rPr lang="en-US" sz="1400" dirty="0">
-                <a:solidFill>
-                  <a:schemeClr val="tx1"/>
-                </a:solidFill>
-              </a:rPr>
-              <a:t> – gõ thiếu số 0 đầu vẫn tìm được</a:t>
+                  <a:schemeClr val="bg1"/>
+                </a:solidFill>
+              </a:rPr>
+              <a:t>loại minh chứng + giờ trong ảnh + nơi nhận (Zalo / yêu cầu hỗ trợ ngày …).</a:t>
             </a:r>
             <a:endParaRPr lang="en-US" sz="1400" dirty="0"/>
-          </a:p>
-        </p:txBody>
-      </p:sp>
-      <p:sp>
-        <p:nvSpPr>
-          <p:cNvPr id="9" name="So 3"/>
-          <p:cNvSpPr/>
-          <p:nvPr/>
-        </p:nvSpPr>
-        <p:spPr>
-          <a:xfrm>
-            <a:off x="457200" y="2688336"/>
-            <a:ext cx="365760" cy="365760"/>
-          </a:xfrm>
-          <a:prstGeom prst="ellipse">
-            <a:avLst/>
-          </a:prstGeom>
-          <a:solidFill>
-            <a:schemeClr val="tx2"/>
-          </a:solidFill>
-          <a:ln/>
-        </p:spPr>
-      </p:sp>
-      <p:sp>
-        <p:nvSpPr>
-          <p:cNvPr id="10" name="Text 8"/>
-          <p:cNvSpPr txBox="1"/>
-          <p:nvPr/>
-        </p:nvSpPr>
-        <p:spPr>
-          <a:xfrm>
-            <a:off x="457200" y="2688336"/>
-            <a:ext cx="365760" cy="365760"/>
-          </a:xfrm>
-          <a:prstGeom prst="rect">
-            <a:avLst/>
-          </a:prstGeom>
-          <a:noFill/>
-          <a:ln/>
-        </p:spPr>
-        <p:txBody>
-          <a:bodyPr wrap="square" lIns="0" tIns="0" rIns="0" bIns="0" rtlCol="0" anchor="ctr"/>
-          <a:lstStyle/>
-          <a:p>
-            <a:pPr algn="ctr" indent="0" marL="0">
-              <a:buNone/>
-            </a:pPr>
-            <a:r>
-              <a:rPr lang="en-US" sz="1600" b="1" dirty="0">
-                <a:solidFill>
-                  <a:schemeClr val="bg1"/>
-                </a:solidFill>
-              </a:rPr>
-              <a:t>3</a:t>
-            </a:r>
-            <a:endParaRPr lang="en-US" sz="1600" dirty="0"/>
-          </a:p>
-        </p:txBody>
-      </p:sp>
-      <p:sp>
-        <p:nvSpPr>
-          <p:cNvPr id="11" name="Text 9"/>
-          <p:cNvSpPr txBox="1"/>
-          <p:nvPr/>
-        </p:nvSpPr>
-        <p:spPr>
-          <a:xfrm>
-            <a:off x="960120" y="2651760"/>
-            <a:ext cx="3703320" cy="694944"/>
-          </a:xfrm>
-          <a:prstGeom prst="rect">
-            <a:avLst/>
-          </a:prstGeom>
-          <a:noFill/>
-          <a:ln/>
-        </p:spPr>
-        <p:txBody>
-          <a:bodyPr wrap="square" lIns="0" tIns="0" rIns="0" bIns="0" rtlCol="0" anchor="t"/>
-          <a:lstStyle/>
-          <a:p>
-            <a:pPr indent="0" marL="0">
-              <a:buNone/>
-            </a:pPr>
-            <a:r>
-              <a:rPr lang="en-US" sz="1400" dirty="0">
-                <a:solidFill>
-                  <a:schemeClr val="tx1"/>
-                </a:solidFill>
-              </a:rPr>
-              <a:t>Lọc thêm: </a:t>
-            </a:r>
-            <a:pPr indent="0" marL="0">
-              <a:buNone/>
-            </a:pPr>
-            <a:r>
-              <a:rPr lang="en-US" sz="1400" b="1" dirty="0">
-                <a:solidFill>
-                  <a:schemeClr val="tx1"/>
-                </a:solidFill>
-              </a:rPr>
-              <a:t>Phạm vi</a:t>
-            </a:r>
-            <a:pPr indent="0" marL="0">
-              <a:buNone/>
-            </a:pPr>
-            <a:r>
-              <a:rPr lang="en-US" sz="1400" dirty="0">
-                <a:solidFill>
-                  <a:schemeClr val="tx1"/>
-                </a:solidFill>
-              </a:rPr>
-              <a:t> (Tất cả · Cụm của tôi · Lớp tôi hỗ trợ), trường, cụm, lớp</a:t>
-            </a:r>
-            <a:endParaRPr lang="en-US" sz="1400" dirty="0"/>
-          </a:p>
-        </p:txBody>
-      </p:sp>
-      <p:sp>
-        <p:nvSpPr>
-          <p:cNvPr id="12" name="So 4"/>
-          <p:cNvSpPr/>
-          <p:nvPr/>
-        </p:nvSpPr>
-        <p:spPr>
-          <a:xfrm>
-            <a:off x="457200" y="3438144"/>
-            <a:ext cx="365760" cy="365760"/>
-          </a:xfrm>
-          <a:prstGeom prst="ellipse">
-            <a:avLst/>
-          </a:prstGeom>
-          <a:solidFill>
-            <a:schemeClr val="tx2"/>
-          </a:solidFill>
-          <a:ln/>
-        </p:spPr>
-      </p:sp>
-      <p:sp>
-        <p:nvSpPr>
-          <p:cNvPr id="13" name="Text 11"/>
-          <p:cNvSpPr txBox="1"/>
-          <p:nvPr/>
-        </p:nvSpPr>
-        <p:spPr>
-          <a:xfrm>
-            <a:off x="457200" y="3438144"/>
-            <a:ext cx="365760" cy="365760"/>
-          </a:xfrm>
-          <a:prstGeom prst="rect">
-            <a:avLst/>
-          </a:prstGeom>
-          <a:noFill/>
-          <a:ln/>
-        </p:spPr>
-        <p:txBody>
-          <a:bodyPr wrap="square" lIns="0" tIns="0" rIns="0" bIns="0" rtlCol="0" anchor="ctr"/>
-          <a:lstStyle/>
-          <a:p>
-            <a:pPr algn="ctr" indent="0" marL="0">
-              <a:buNone/>
-            </a:pPr>
-            <a:r>
-              <a:rPr lang="en-US" sz="1600" b="1" dirty="0">
-                <a:solidFill>
-                  <a:schemeClr val="bg1"/>
-                </a:solidFill>
-              </a:rPr>
-              <a:t>4</a:t>
-            </a:r>
-            <a:endParaRPr lang="en-US" sz="1600" dirty="0"/>
-          </a:p>
-        </p:txBody>
-      </p:sp>
-      <p:sp>
-        <p:nvSpPr>
-          <p:cNvPr id="14" name="Text 12"/>
-          <p:cNvSpPr txBox="1"/>
-          <p:nvPr/>
-        </p:nvSpPr>
-        <p:spPr>
-          <a:xfrm>
-            <a:off x="960120" y="3401568"/>
-            <a:ext cx="3703320" cy="694944"/>
-          </a:xfrm>
-          <a:prstGeom prst="rect">
-            <a:avLst/>
-          </a:prstGeom>
-          <a:noFill/>
-          <a:ln/>
-        </p:spPr>
-        <p:txBody>
-          <a:bodyPr wrap="square" lIns="0" tIns="0" rIns="0" bIns="0" rtlCol="0" anchor="t"/>
-          <a:lstStyle/>
-          <a:p>
-            <a:pPr indent="0" marL="0">
-              <a:buNone/>
-            </a:pPr>
-            <a:r>
-              <a:rPr lang="en-US" sz="1400" dirty="0">
-                <a:solidFill>
-                  <a:schemeClr val="tx1"/>
-                </a:solidFill>
-              </a:rPr>
-              <a:t>Bấm </a:t>
-            </a:r>
-            <a:pPr indent="0" marL="0">
-              <a:buNone/>
-            </a:pPr>
-            <a:r>
-              <a:rPr lang="en-US" sz="1400" b="1" dirty="0">
-                <a:solidFill>
-                  <a:schemeClr val="tx1"/>
-                </a:solidFill>
-              </a:rPr>
-              <a:t>tên học viên</a:t>
-            </a:r>
-            <a:pPr indent="0" marL="0">
-              <a:buNone/>
-            </a:pPr>
-            <a:r>
-              <a:rPr lang="en-US" sz="1400" dirty="0">
-                <a:solidFill>
-                  <a:schemeClr val="tx1"/>
-                </a:solidFill>
-              </a:rPr>
-              <a:t> để mở chi tiết từng buổi</a:t>
-            </a:r>
-            <a:endParaRPr lang="en-US" sz="1400" dirty="0"/>
-          </a:p>
-        </p:txBody>
-      </p:sp>
-      <p:sp>
-        <p:nvSpPr>
-          <p:cNvPr id="15" name="Cot bang"/>
-          <p:cNvSpPr/>
-          <p:nvPr/>
-        </p:nvSpPr>
-        <p:spPr>
-          <a:xfrm>
-            <a:off x="4937760" y="1097280"/>
-            <a:ext cx="3749040" cy="3383280"/>
-          </a:xfrm>
-          <a:prstGeom prst="roundRect">
-            <a:avLst>
-              <a:gd name="adj" fmla="val 2162"/>
-            </a:avLst>
-          </a:prstGeom>
-          <a:solidFill>
-            <a:schemeClr val="bg2"/>
-          </a:solidFill>
-          <a:ln/>
-        </p:spPr>
-      </p:sp>
-      <p:sp>
-        <p:nvSpPr>
-          <p:cNvPr id="16" name="Text 14"/>
-          <p:cNvSpPr txBox="1"/>
-          <p:nvPr/>
-        </p:nvSpPr>
-        <p:spPr>
-          <a:xfrm>
-            <a:off x="5120640" y="1207008"/>
-            <a:ext cx="3383280" cy="320040"/>
-          </a:xfrm>
-          <a:prstGeom prst="rect">
-            <a:avLst/>
-          </a:prstGeom>
-          <a:noFill/>
-          <a:ln/>
-        </p:spPr>
-        <p:txBody>
-          <a:bodyPr wrap="square" lIns="0" tIns="0" rIns="0" bIns="0" rtlCol="0" anchor="ctr"/>
-          <a:lstStyle/>
-          <a:p>
-            <a:pPr indent="0" marL="0">
-              <a:buNone/>
-            </a:pPr>
-            <a:r>
-              <a:rPr lang="en-US" sz="1600" b="1" dirty="0">
-                <a:solidFill>
-                  <a:schemeClr val="tx2"/>
-                </a:solidFill>
-              </a:rPr>
-              <a:t>Các cột số liệu</a:t>
-            </a:r>
-            <a:endParaRPr lang="en-US" sz="1600" dirty="0"/>
-          </a:p>
-        </p:txBody>
-      </p:sp>
-      <p:sp>
-        <p:nvSpPr>
-          <p:cNvPr id="17" name="Nhan Có mặt/đã diễn ra"/>
-          <p:cNvSpPr/>
-          <p:nvPr/>
-        </p:nvSpPr>
-        <p:spPr>
-          <a:xfrm>
-            <a:off x="5120640" y="1664208"/>
-            <a:ext cx="1920240" cy="329184"/>
-          </a:xfrm>
-          <a:prstGeom prst="roundRect">
-            <a:avLst>
-              <a:gd name="adj" fmla="val 50000"/>
-            </a:avLst>
-          </a:prstGeom>
-          <a:solidFill>
-            <a:schemeClr val="accent1">
-              <a:alpha val="22000"/>
-            </a:schemeClr>
-          </a:solidFill>
-          <a:ln w="12700">
-            <a:solidFill>
-              <a:schemeClr val="accent1"/>
-            </a:solidFill>
-            <a:prstDash val="solid"/>
-          </a:ln>
-        </p:spPr>
-      </p:sp>
-      <p:sp>
-        <p:nvSpPr>
-          <p:cNvPr id="18" name="Text 16"/>
-          <p:cNvSpPr txBox="1"/>
-          <p:nvPr/>
-        </p:nvSpPr>
-        <p:spPr>
-          <a:xfrm>
-            <a:off x="5120640" y="1664208"/>
-            <a:ext cx="1920240" cy="329184"/>
-          </a:xfrm>
-          <a:prstGeom prst="rect">
-            <a:avLst/>
-          </a:prstGeom>
-          <a:noFill/>
-          <a:ln/>
-        </p:spPr>
-        <p:txBody>
-          <a:bodyPr wrap="square" lIns="0" tIns="0" rIns="0" bIns="0" rtlCol="0" anchor="ctr"/>
-          <a:lstStyle/>
-          <a:p>
-            <a:pPr algn="ctr" indent="0" marL="0">
-              <a:buNone/>
-            </a:pPr>
-            <a:r>
-              <a:rPr lang="en-US" sz="1200" b="1" dirty="0">
-                <a:solidFill>
-                  <a:schemeClr val="accent1"/>
-                </a:solidFill>
-              </a:rPr>
-              <a:t>Có mặt/đã diễn ra</a:t>
-            </a:r>
-            <a:endParaRPr lang="en-US" sz="1200" dirty="0"/>
-          </a:p>
-        </p:txBody>
-      </p:sp>
-      <p:sp>
-        <p:nvSpPr>
-          <p:cNvPr id="19" name="Nhan Vắng"/>
-          <p:cNvSpPr/>
-          <p:nvPr/>
-        </p:nvSpPr>
-        <p:spPr>
-          <a:xfrm>
-            <a:off x="5120640" y="2121408"/>
-            <a:ext cx="1920240" cy="329184"/>
-          </a:xfrm>
-          <a:prstGeom prst="roundRect">
-            <a:avLst>
-              <a:gd name="adj" fmla="val 50000"/>
-            </a:avLst>
-          </a:prstGeom>
-          <a:solidFill>
-            <a:schemeClr val="accent3">
-              <a:alpha val="22000"/>
-            </a:schemeClr>
-          </a:solidFill>
-          <a:ln w="12700">
-            <a:solidFill>
-              <a:schemeClr val="accent3"/>
-            </a:solidFill>
-            <a:prstDash val="solid"/>
-          </a:ln>
-        </p:spPr>
-      </p:sp>
-      <p:sp>
-        <p:nvSpPr>
-          <p:cNvPr id="20" name="Text 18"/>
-          <p:cNvSpPr txBox="1"/>
-          <p:nvPr/>
-        </p:nvSpPr>
-        <p:spPr>
-          <a:xfrm>
-            <a:off x="5120640" y="2121408"/>
-            <a:ext cx="1920240" cy="329184"/>
-          </a:xfrm>
-          <a:prstGeom prst="rect">
-            <a:avLst/>
-          </a:prstGeom>
-          <a:noFill/>
-          <a:ln/>
-        </p:spPr>
-        <p:txBody>
-          <a:bodyPr wrap="square" lIns="0" tIns="0" rIns="0" bIns="0" rtlCol="0" anchor="ctr"/>
-          <a:lstStyle/>
-          <a:p>
-            <a:pPr algn="ctr" indent="0" marL="0">
-              <a:buNone/>
-            </a:pPr>
-            <a:r>
-              <a:rPr lang="en-US" sz="1200" b="1" dirty="0">
-                <a:solidFill>
-                  <a:schemeClr val="accent3"/>
-                </a:solidFill>
-              </a:rPr>
-              <a:t>Vắng</a:t>
-            </a:r>
-            <a:endParaRPr lang="en-US" sz="1200" dirty="0"/>
-          </a:p>
-        </p:txBody>
-      </p:sp>
-      <p:sp>
-        <p:nvSpPr>
-          <p:cNvPr id="21" name="Nhan Có phép"/>
-          <p:cNvSpPr/>
-          <p:nvPr/>
-        </p:nvSpPr>
-        <p:spPr>
-          <a:xfrm>
-            <a:off x="5120640" y="2578608"/>
-            <a:ext cx="1920240" cy="329184"/>
-          </a:xfrm>
-          <a:prstGeom prst="roundRect">
-            <a:avLst>
-              <a:gd name="adj" fmla="val 50000"/>
-            </a:avLst>
-          </a:prstGeom>
-          <a:solidFill>
-            <a:schemeClr val="accent2">
-              <a:alpha val="22000"/>
-            </a:schemeClr>
-          </a:solidFill>
-          <a:ln w="12700">
-            <a:solidFill>
-              <a:schemeClr val="accent2"/>
-            </a:solidFill>
-            <a:prstDash val="solid"/>
-          </a:ln>
-        </p:spPr>
-      </p:sp>
-      <p:sp>
-        <p:nvSpPr>
-          <p:cNvPr id="22" name="Text 20"/>
-          <p:cNvSpPr txBox="1"/>
-          <p:nvPr/>
-        </p:nvSpPr>
-        <p:spPr>
-          <a:xfrm>
-            <a:off x="5120640" y="2578608"/>
-            <a:ext cx="1920240" cy="329184"/>
-          </a:xfrm>
-          <a:prstGeom prst="rect">
-            <a:avLst/>
-          </a:prstGeom>
-          <a:noFill/>
-          <a:ln/>
-        </p:spPr>
-        <p:txBody>
-          <a:bodyPr wrap="square" lIns="0" tIns="0" rIns="0" bIns="0" rtlCol="0" anchor="ctr"/>
-          <a:lstStyle/>
-          <a:p>
-            <a:pPr algn="ctr" indent="0" marL="0">
-              <a:buNone/>
-            </a:pPr>
-            <a:r>
-              <a:rPr lang="en-US" sz="1200" b="1" dirty="0">
-                <a:solidFill>
-                  <a:schemeClr val="accent2"/>
-                </a:solidFill>
-              </a:rPr>
-              <a:t>Có phép</a:t>
-            </a:r>
-            <a:endParaRPr lang="en-US" sz="1200" dirty="0"/>
-          </a:p>
-        </p:txBody>
-      </p:sp>
-      <p:sp>
-        <p:nvSpPr>
-          <p:cNvPr id="23" name="Nhan Báo vắng"/>
-          <p:cNvSpPr/>
-          <p:nvPr/>
-        </p:nvSpPr>
-        <p:spPr>
-          <a:xfrm>
-            <a:off x="5120640" y="3035808"/>
-            <a:ext cx="1920240" cy="329184"/>
-          </a:xfrm>
-          <a:prstGeom prst="roundRect">
-            <a:avLst>
-              <a:gd name="adj" fmla="val 50000"/>
-            </a:avLst>
-          </a:prstGeom>
-          <a:solidFill>
-            <a:schemeClr val="accent5">
-              <a:alpha val="22000"/>
-            </a:schemeClr>
-          </a:solidFill>
-          <a:ln w="12700">
-            <a:solidFill>
-              <a:schemeClr val="accent5"/>
-            </a:solidFill>
-            <a:prstDash val="solid"/>
-          </a:ln>
-        </p:spPr>
-      </p:sp>
-      <p:sp>
-        <p:nvSpPr>
-          <p:cNvPr id="24" name="Text 22"/>
-          <p:cNvSpPr txBox="1"/>
-          <p:nvPr/>
-        </p:nvSpPr>
-        <p:spPr>
-          <a:xfrm>
-            <a:off x="5120640" y="3035808"/>
-            <a:ext cx="1920240" cy="329184"/>
-          </a:xfrm>
-          <a:prstGeom prst="rect">
-            <a:avLst/>
-          </a:prstGeom>
-          <a:noFill/>
-          <a:ln/>
-        </p:spPr>
-        <p:txBody>
-          <a:bodyPr wrap="square" lIns="0" tIns="0" rIns="0" bIns="0" rtlCol="0" anchor="ctr"/>
-          <a:lstStyle/>
-          <a:p>
-            <a:pPr algn="ctr" indent="0" marL="0">
-              <a:buNone/>
-            </a:pPr>
-            <a:r>
-              <a:rPr lang="en-US" sz="1200" b="1" dirty="0">
-                <a:solidFill>
-                  <a:schemeClr val="accent5"/>
-                </a:solidFill>
-              </a:rPr>
-              <a:t>Báo vắng</a:t>
-            </a:r>
-            <a:endParaRPr lang="en-US" sz="1200" dirty="0"/>
-          </a:p>
-        </p:txBody>
-      </p:sp>
-      <p:sp>
-        <p:nvSpPr>
-          <p:cNvPr id="25" name="Nhan Chưa điểm danh"/>
-          <p:cNvSpPr/>
-          <p:nvPr/>
-        </p:nvSpPr>
-        <p:spPr>
-          <a:xfrm>
-            <a:off x="5120640" y="3493008"/>
-            <a:ext cx="1920240" cy="329184"/>
-          </a:xfrm>
-          <a:prstGeom prst="roundRect">
-            <a:avLst>
-              <a:gd name="adj" fmla="val 50000"/>
-            </a:avLst>
-          </a:prstGeom>
-          <a:solidFill>
-            <a:schemeClr val="accent5">
-              <a:alpha val="22000"/>
-            </a:schemeClr>
-          </a:solidFill>
-          <a:ln w="12700">
-            <a:solidFill>
-              <a:schemeClr val="accent5"/>
-            </a:solidFill>
-            <a:prstDash val="solid"/>
-          </a:ln>
-        </p:spPr>
-      </p:sp>
-      <p:sp>
-        <p:nvSpPr>
-          <p:cNvPr id="26" name="Text 24"/>
-          <p:cNvSpPr txBox="1"/>
-          <p:nvPr/>
-        </p:nvSpPr>
-        <p:spPr>
-          <a:xfrm>
-            <a:off x="5120640" y="3493008"/>
-            <a:ext cx="1920240" cy="329184"/>
-          </a:xfrm>
-          <a:prstGeom prst="rect">
-            <a:avLst/>
-          </a:prstGeom>
-          <a:noFill/>
-          <a:ln/>
-        </p:spPr>
-        <p:txBody>
-          <a:bodyPr wrap="square" lIns="0" tIns="0" rIns="0" bIns="0" rtlCol="0" anchor="ctr"/>
-          <a:lstStyle/>
-          <a:p>
-            <a:pPr algn="ctr" indent="0" marL="0">
-              <a:buNone/>
-            </a:pPr>
-            <a:r>
-              <a:rPr lang="en-US" sz="1200" b="1" dirty="0">
-                <a:solidFill>
-                  <a:schemeClr val="accent5"/>
-                </a:solidFill>
-              </a:rPr>
-              <a:t>Chưa điểm danh</a:t>
-            </a:r>
-            <a:endParaRPr lang="en-US" sz="1200" dirty="0"/>
-          </a:p>
-        </p:txBody>
-      </p:sp>
-      <p:sp>
-        <p:nvSpPr>
-          <p:cNvPr id="27" name="Text 25"/>
-          <p:cNvSpPr txBox="1"/>
-          <p:nvPr/>
-        </p:nvSpPr>
-        <p:spPr>
-          <a:xfrm>
-            <a:off x="5120640" y="3931920"/>
-            <a:ext cx="3383280" cy="457200"/>
-          </a:xfrm>
-          <a:prstGeom prst="rect">
-            <a:avLst/>
-          </a:prstGeom>
-          <a:noFill/>
-          <a:ln/>
-        </p:spPr>
-        <p:txBody>
-          <a:bodyPr wrap="square" lIns="0" tIns="0" rIns="0" bIns="0" rtlCol="0" anchor="t"/>
-          <a:lstStyle/>
-          <a:p>
-            <a:pPr indent="0" marL="0">
-              <a:buNone/>
-            </a:pPr>
-            <a:r>
-              <a:rPr lang="en-US" sz="1200" dirty="0">
-                <a:solidFill>
-                  <a:schemeClr val="tx1"/>
-                </a:solidFill>
-              </a:rPr>
-              <a:t>Xuất Excel: đủ mọi dòng khớp bộ lọc; có họ tên – chỉ dùng nội bộ.</a:t>
-            </a:r>
-            <a:endParaRPr lang="en-US" sz="1200" dirty="0"/>
           </a:p>
         </p:txBody>
       </p:sp>
@@ -4704,7 +4308,7 @@
                   <a:schemeClr val="tx2"/>
                 </a:solidFill>
               </a:rPr>
-              <a:t>Ghi điểm danh bổ sung</a:t>
+              <a:t>Tra cứu học viên – menu Tình hình đi học</a:t>
             </a:r>
             <a:endParaRPr lang="en-US" sz="2800" dirty="0"/>
           </a:p>
@@ -4718,7 +4322,7 @@
         </p:nvSpPr>
         <p:spPr>
           <a:xfrm>
-            <a:off x="457200" y="1188720"/>
+            <a:off x="457200" y="1143000"/>
             <a:ext cx="365760" cy="365760"/>
           </a:xfrm>
           <a:prstGeom prst="ellipse">
@@ -4738,7 +4342,7 @@
         </p:nvSpPr>
         <p:spPr>
           <a:xfrm>
-            <a:off x="457200" y="1188720"/>
+            <a:off x="457200" y="1143000"/>
             <a:ext cx="365760" cy="365760"/>
           </a:xfrm>
           <a:prstGeom prst="rect">
@@ -4774,8 +4378,8 @@
         </p:nvSpPr>
         <p:spPr>
           <a:xfrm>
-            <a:off x="960120" y="1152144"/>
-            <a:ext cx="4069080" cy="603504"/>
+            <a:off x="960120" y="1106424"/>
+            <a:ext cx="4617720" cy="603504"/>
           </a:xfrm>
           <a:prstGeom prst="rect">
             <a:avLst/>
@@ -4796,7 +4400,7 @@
                   <a:schemeClr val="tx1"/>
                 </a:solidFill>
               </a:rPr>
-              <a:t>Trong chi tiết, tìm đúng buổi: </a:t>
+              <a:t>Chọn </a:t>
             </a:r>
             <a:pPr indent="0" marL="0">
               <a:buNone/>
@@ -4807,7 +4411,18 @@
                   <a:schemeClr val="tx1"/>
                 </a:solidFill>
               </a:rPr>
-              <a:t>GĐ · Buổi · Lớp · giờ</a:t>
+              <a:t>Khóa</a:t>
+            </a:r>
+            <a:pPr indent="0" marL="0">
+              <a:buNone/>
+            </a:pPr>
+            <a:r>
+              <a:rPr lang="en-US" sz="1400" dirty="0">
+                <a:solidFill>
+                  <a:schemeClr val="tx1"/>
+                </a:solidFill>
+              </a:rPr>
+              <a:t> (bắt buộc)</a:t>
             </a:r>
             <a:endParaRPr lang="en-US" sz="1400" dirty="0"/>
           </a:p>
@@ -4821,7 +4436,7 @@
         </p:nvSpPr>
         <p:spPr>
           <a:xfrm>
-            <a:off x="457200" y="1847088"/>
+            <a:off x="457200" y="1801368"/>
             <a:ext cx="365760" cy="365760"/>
           </a:xfrm>
           <a:prstGeom prst="ellipse">
@@ -4841,7 +4456,7 @@
         </p:nvSpPr>
         <p:spPr>
           <a:xfrm>
-            <a:off x="457200" y="1847088"/>
+            <a:off x="457200" y="1801368"/>
             <a:ext cx="365760" cy="365760"/>
           </a:xfrm>
           <a:prstGeom prst="rect">
@@ -4877,8 +4492,8 @@
         </p:nvSpPr>
         <p:spPr>
           <a:xfrm>
-            <a:off x="960120" y="1810512"/>
-            <a:ext cx="4069080" cy="603504"/>
+            <a:off x="960120" y="1764792"/>
+            <a:ext cx="4617720" cy="603504"/>
           </a:xfrm>
           <a:prstGeom prst="rect">
             <a:avLst/>
@@ -4899,7 +4514,7 @@
                   <a:schemeClr val="tx1"/>
                 </a:solidFill>
               </a:rPr>
-              <a:t>Bấm </a:t>
+              <a:t>Gõ </a:t>
             </a:r>
             <a:pPr indent="0" marL="0">
               <a:buNone/>
@@ -4910,7 +4525,18 @@
                   <a:schemeClr val="tx1"/>
                 </a:solidFill>
               </a:rPr>
-              <a:t>Điểm danh bổ sung</a:t>
+              <a:t>họ tên hoặc mã MOET</a:t>
+            </a:r>
+            <a:pPr indent="0" marL="0">
+              <a:buNone/>
+            </a:pPr>
+            <a:r>
+              <a:rPr lang="en-US" sz="1400" dirty="0">
+                <a:solidFill>
+                  <a:schemeClr val="tx1"/>
+                </a:solidFill>
+              </a:rPr>
+              <a:t> – thiếu số 0 đầu vẫn tìm được</a:t>
             </a:r>
             <a:endParaRPr lang="en-US" sz="1400" dirty="0"/>
           </a:p>
@@ -4924,7 +4550,7 @@
         </p:nvSpPr>
         <p:spPr>
           <a:xfrm>
-            <a:off x="457200" y="2505456"/>
+            <a:off x="457200" y="2459736"/>
             <a:ext cx="365760" cy="365760"/>
           </a:xfrm>
           <a:prstGeom prst="ellipse">
@@ -4944,7 +4570,7 @@
         </p:nvSpPr>
         <p:spPr>
           <a:xfrm>
-            <a:off x="457200" y="2505456"/>
+            <a:off x="457200" y="2459736"/>
             <a:ext cx="365760" cy="365760"/>
           </a:xfrm>
           <a:prstGeom prst="rect">
@@ -4980,8 +4606,8 @@
         </p:nvSpPr>
         <p:spPr>
           <a:xfrm>
-            <a:off x="960120" y="2468880"/>
-            <a:ext cx="4069080" cy="603504"/>
+            <a:off x="960120" y="2423160"/>
+            <a:ext cx="4617720" cy="603504"/>
           </a:xfrm>
           <a:prstGeom prst="rect">
             <a:avLst/>
@@ -5002,7 +4628,7 @@
                   <a:schemeClr val="tx1"/>
                 </a:solidFill>
               </a:rPr>
-              <a:t>Chọn </a:t>
+              <a:t>Lọc thêm: phạm vi, trường, cụm, lớp; </a:t>
             </a:r>
             <a:pPr indent="0" marL="0">
               <a:buNone/>
@@ -5010,32 +4636,10 @@
             <a:r>
               <a:rPr lang="en-US" sz="1400" b="1" dirty="0">
                 <a:solidFill>
-                  <a:schemeClr val="accent1"/>
-                </a:solidFill>
-              </a:rPr>
-              <a:t>Có mặt</a:t>
-            </a:r>
-            <a:pPr indent="0" marL="0">
-              <a:buNone/>
-            </a:pPr>
-            <a:r>
-              <a:rPr lang="en-US" sz="1400" dirty="0">
-                <a:solidFill>
                   <a:schemeClr val="tx1"/>
                 </a:solidFill>
               </a:rPr>
-              <a:t> hoặc </a:t>
-            </a:r>
-            <a:pPr indent="0" marL="0">
-              <a:buNone/>
-            </a:pPr>
-            <a:r>
-              <a:rPr lang="en-US" sz="1400" b="1" dirty="0">
-                <a:solidFill>
-                  <a:schemeClr val="accent2"/>
-                </a:solidFill>
-              </a:rPr>
-              <a:t>Vắng có phép</a:t>
+              <a:t>Có buổi vắng / chưa điểm danh</a:t>
             </a:r>
             <a:endParaRPr lang="en-US" sz="1400" dirty="0"/>
           </a:p>
@@ -5049,7 +4653,7 @@
         </p:nvSpPr>
         <p:spPr>
           <a:xfrm>
-            <a:off x="457200" y="3163824"/>
+            <a:off x="457200" y="3118104"/>
             <a:ext cx="365760" cy="365760"/>
           </a:xfrm>
           <a:prstGeom prst="ellipse">
@@ -5069,7 +4673,7 @@
         </p:nvSpPr>
         <p:spPr>
           <a:xfrm>
-            <a:off x="457200" y="3163824"/>
+            <a:off x="457200" y="3118104"/>
             <a:ext cx="365760" cy="365760"/>
           </a:xfrm>
           <a:prstGeom prst="rect">
@@ -5105,8 +4709,8 @@
         </p:nvSpPr>
         <p:spPr>
           <a:xfrm>
-            <a:off x="960120" y="3127248"/>
-            <a:ext cx="4069080" cy="603504"/>
+            <a:off x="960120" y="3081528"/>
+            <a:ext cx="4617720" cy="603504"/>
           </a:xfrm>
           <a:prstGeom prst="rect">
             <a:avLst/>
@@ -5127,7 +4731,7 @@
                   <a:schemeClr val="tx1"/>
                 </a:solidFill>
               </a:rPr>
-              <a:t>Nhập </a:t>
+              <a:t>Bấm </a:t>
             </a:r>
             <a:pPr indent="0" marL="0">
               <a:buNone/>
@@ -5138,7 +4742,7 @@
                   <a:schemeClr val="tx1"/>
                 </a:solidFill>
               </a:rPr>
-              <a:t>Lý do</a:t>
+              <a:t>tên học viên</a:t>
             </a:r>
             <a:pPr indent="0" marL="0">
               <a:buNone/>
@@ -5149,7 +4753,7 @@
                   <a:schemeClr val="tx1"/>
                 </a:solidFill>
               </a:rPr>
-              <a:t> – ghi rõ minh chứng gì, nhận khi nào</a:t>
+              <a:t> để mở chi tiết từng buổi</a:t>
             </a:r>
             <a:endParaRPr lang="en-US" sz="1400" dirty="0"/>
           </a:p>
@@ -5157,172 +4761,123 @@
       </p:sp>
       <p:sp>
         <p:nvSpPr>
-          <p:cNvPr id="15" name="So 5"/>
+          <p:cNvPr id="15" name="Text 13"/>
+          <p:cNvSpPr txBox="1"/>
+          <p:nvPr/>
+        </p:nvSpPr>
+        <p:spPr>
+          <a:xfrm>
+            <a:off x="457200" y="3931920"/>
+            <a:ext cx="5120640" cy="457200"/>
+          </a:xfrm>
+          <a:prstGeom prst="rect">
+            <a:avLst/>
+          </a:prstGeom>
+          <a:noFill/>
+          <a:ln/>
+        </p:spPr>
+        <p:txBody>
+          <a:bodyPr wrap="square" lIns="0" tIns="0" rIns="0" bIns="0" rtlCol="0" anchor="t"/>
+          <a:lstStyle/>
+          <a:p>
+            <a:pPr indent="0" marL="0">
+              <a:buNone/>
+            </a:pPr>
+            <a:r>
+              <a:rPr lang="en-US" sz="1200" i="1" dirty="0">
+                <a:solidFill>
+                  <a:schemeClr val="accent5"/>
+                </a:solidFill>
+              </a:rPr>
+              <a:t>Xuất Excel: đủ mọi dòng khớp bộ lọc; có họ tên – chỉ dùng nội bộ.</a:t>
+            </a:r>
+            <a:endParaRPr lang="en-US" sz="1200" dirty="0"/>
+          </a:p>
+        </p:txBody>
+      </p:sp>
+      <p:sp>
+        <p:nvSpPr>
+          <p:cNvPr id="16" name="Khung ht-danh-sach"/>
           <p:cNvSpPr/>
           <p:nvPr/>
         </p:nvSpPr>
         <p:spPr>
           <a:xfrm>
-            <a:off x="457200" y="3822192"/>
-            <a:ext cx="365760" cy="365760"/>
-          </a:xfrm>
-          <a:prstGeom prst="ellipse">
-            <a:avLst/>
-          </a:prstGeom>
-          <a:solidFill>
-            <a:schemeClr val="tx2"/>
-          </a:solidFill>
-          <a:ln/>
-        </p:spPr>
-      </p:sp>
-      <p:sp>
-        <p:nvSpPr>
-          <p:cNvPr id="16" name="Text 14"/>
-          <p:cNvSpPr txBox="1"/>
-          <p:nvPr/>
-        </p:nvSpPr>
-        <p:spPr>
-          <a:xfrm>
-            <a:off x="457200" y="3822192"/>
-            <a:ext cx="365760" cy="365760"/>
-          </a:xfrm>
-          <a:prstGeom prst="rect">
-            <a:avLst/>
-          </a:prstGeom>
-          <a:noFill/>
-          <a:ln/>
-        </p:spPr>
-        <p:txBody>
-          <a:bodyPr wrap="square" lIns="0" tIns="0" rIns="0" bIns="0" rtlCol="0" anchor="ctr"/>
-          <a:lstStyle/>
-          <a:p>
-            <a:pPr algn="ctr" indent="0" marL="0">
-              <a:buNone/>
-            </a:pPr>
-            <a:r>
-              <a:rPr lang="en-US" sz="1600" b="1" dirty="0">
-                <a:solidFill>
-                  <a:schemeClr val="bg1"/>
-                </a:solidFill>
-              </a:rPr>
-              <a:t>5</a:t>
-            </a:r>
-            <a:endParaRPr lang="en-US" sz="1600" dirty="0"/>
-          </a:p>
-        </p:txBody>
-      </p:sp>
-      <p:sp>
-        <p:nvSpPr>
-          <p:cNvPr id="17" name="Text 15"/>
-          <p:cNvSpPr txBox="1"/>
-          <p:nvPr/>
-        </p:nvSpPr>
-        <p:spPr>
-          <a:xfrm>
-            <a:off x="960120" y="3785616"/>
-            <a:ext cx="4069080" cy="603504"/>
-          </a:xfrm>
-          <a:prstGeom prst="rect">
-            <a:avLst/>
-          </a:prstGeom>
-          <a:noFill/>
-          <a:ln/>
-        </p:spPr>
-        <p:txBody>
-          <a:bodyPr wrap="square" lIns="0" tIns="0" rIns="0" bIns="0" rtlCol="0" anchor="t"/>
-          <a:lstStyle/>
-          <a:p>
-            <a:pPr indent="0" marL="0">
-              <a:buNone/>
-            </a:pPr>
-            <a:r>
-              <a:rPr lang="en-US" sz="1400" dirty="0">
-                <a:solidFill>
-                  <a:schemeClr val="tx1"/>
-                </a:solidFill>
-              </a:rPr>
-              <a:t>Bấm </a:t>
-            </a:r>
-            <a:pPr indent="0" marL="0">
-              <a:buNone/>
-            </a:pPr>
-            <a:r>
-              <a:rPr lang="en-US" sz="1400" b="1" dirty="0">
-                <a:solidFill>
-                  <a:schemeClr val="tx1"/>
-                </a:solidFill>
-              </a:rPr>
-              <a:t>Xác nhận</a:t>
-            </a:r>
-            <a:pPr indent="0" marL="0">
-              <a:buNone/>
-            </a:pPr>
-            <a:r>
-              <a:rPr lang="en-US" sz="1400" dirty="0">
-                <a:solidFill>
-                  <a:schemeClr val="tx1"/>
-                </a:solidFill>
-              </a:rPr>
-              <a:t> → thẻ buổi hiện người sửa, thời điểm và lý do</a:t>
-            </a:r>
-            <a:endParaRPr lang="en-US" sz="1400" dirty="0"/>
-          </a:p>
-        </p:txBody>
-      </p:sp>
-      <p:sp>
-        <p:nvSpPr>
-          <p:cNvPr id="18" name="Dien thoai"/>
-          <p:cNvSpPr/>
-          <p:nvPr/>
-        </p:nvSpPr>
-        <p:spPr>
-          <a:xfrm>
-            <a:off x="5760720" y="1005840"/>
-            <a:ext cx="2514600" cy="3611880"/>
+            <a:off x="6656832" y="987552"/>
+            <a:ext cx="1865376" cy="3602736"/>
           </a:xfrm>
           <a:prstGeom prst="roundRect">
             <a:avLst>
-              <a:gd name="adj" fmla="val 9091"/>
+              <a:gd name="adj" fmla="val 5882"/>
             </a:avLst>
           </a:prstGeom>
           <a:solidFill>
             <a:schemeClr val="tx1"/>
           </a:solidFill>
           <a:ln/>
-        </p:spPr>
-      </p:sp>
-      <p:sp>
-        <p:nvSpPr>
-          <p:cNvPr id="19" name="Man hinh"/>
+          <a:effectLst>
+            <a:outerShdw sx="100000" sy="100000" kx="0" ky="0" algn="bl" rotWithShape="0" blurRad="76200" dist="25400" dir="5400000">
+              <a:srgbClr val="1B2A2F">
+                <a:alpha val="25000"/>
+              </a:srgbClr>
+            </a:outerShdw>
+          </a:effectLst>
+        </p:spPr>
+      </p:sp>
+      <p:pic>
+        <p:nvPicPr>
+          <p:cNvPr id="17" name="Anh ht-danh-sach" descr="Màn Tình hình đi học: chọn khóa, lọc Có buổi vắng, danh sách học viên">    </p:cNvPr>
+          <p:cNvPicPr>
+            <a:picLocks noChangeAspect="1"/>
+          </p:cNvPicPr>
+          <p:nvPr/>
+        </p:nvPicPr>
+        <p:blipFill>
+          <a:blip r:embed="rId1"/>
+          <a:stretch>
+            <a:fillRect/>
+          </a:stretch>
+        </p:blipFill>
+        <p:spPr>
+          <a:xfrm>
+            <a:off x="6720840" y="1051560"/>
+            <a:ext cx="1737360" cy="3474720"/>
+          </a:xfrm>
+          <a:prstGeom prst="rect">
+            <a:avLst/>
+          </a:prstGeom>
+        </p:spPr>
+      </p:pic>
+      <p:sp>
+        <p:nvSpPr>
+          <p:cNvPr id="18" name="So 1"/>
           <p:cNvSpPr/>
           <p:nvPr/>
         </p:nvSpPr>
         <p:spPr>
           <a:xfrm>
-            <a:off x="5870448" y="1143000"/>
-            <a:ext cx="2295144" cy="3337560"/>
-          </a:xfrm>
-          <a:prstGeom prst="roundRect">
-            <a:avLst>
-              <a:gd name="adj" fmla="val 5976"/>
-            </a:avLst>
+            <a:off x="6300216" y="1982419"/>
+            <a:ext cx="292608" cy="292608"/>
+          </a:xfrm>
+          <a:prstGeom prst="ellipse">
+            <a:avLst/>
           </a:prstGeom>
           <a:solidFill>
-            <a:schemeClr val="bg1"/>
+            <a:schemeClr val="accent2"/>
           </a:solidFill>
           <a:ln/>
         </p:spPr>
       </p:sp>
       <p:sp>
         <p:nvSpPr>
-          <p:cNvPr id="20" name="Text 18"/>
+          <p:cNvPr id="19" name="Text 16"/>
           <p:cNvSpPr txBox="1"/>
           <p:nvPr/>
         </p:nvSpPr>
         <p:spPr>
           <a:xfrm>
-            <a:off x="5989320" y="1261872"/>
-            <a:ext cx="2057400" cy="274320"/>
+            <a:off x="6300216" y="1982419"/>
+            <a:ext cx="292608" cy="292608"/>
           </a:xfrm>
           <a:prstGeom prst="rect">
             <a:avLst/>
@@ -5334,116 +4889,163 @@
           <a:bodyPr wrap="square" lIns="0" tIns="0" rIns="0" bIns="0" rtlCol="0" anchor="ctr"/>
           <a:lstStyle/>
           <a:p>
-            <a:pPr indent="0" marL="0">
-              <a:buNone/>
-            </a:pPr>
-            <a:r>
-              <a:rPr lang="en-US" sz="1200" b="1" dirty="0">
-                <a:solidFill>
-                  <a:schemeClr val="tx1"/>
-                </a:solidFill>
-              </a:rPr>
-              <a:t>Điểm danh bổ sung</a:t>
-            </a:r>
-            <a:endParaRPr lang="en-US" sz="1200" dirty="0"/>
-          </a:p>
-        </p:txBody>
-      </p:sp>
-      <p:sp>
-        <p:nvSpPr>
-          <p:cNvPr id="21" name="Text 19"/>
+            <a:pPr algn="ctr" indent="0" marL="0">
+              <a:buNone/>
+            </a:pPr>
+            <a:r>
+              <a:rPr lang="en-US" sz="1300" b="1" dirty="0">
+                <a:solidFill>
+                  <a:schemeClr val="bg1"/>
+                </a:solidFill>
+              </a:rPr>
+              <a:t>1</a:t>
+            </a:r>
+            <a:endParaRPr lang="en-US" sz="1300" dirty="0"/>
+          </a:p>
+        </p:txBody>
+      </p:sp>
+      <p:sp>
+        <p:nvSpPr>
+          <p:cNvPr id="20" name="So 2"/>
+          <p:cNvSpPr/>
+          <p:nvPr/>
+        </p:nvSpPr>
+        <p:spPr>
+          <a:xfrm>
+            <a:off x="6300216" y="2260397"/>
+            <a:ext cx="292608" cy="292608"/>
+          </a:xfrm>
+          <a:prstGeom prst="ellipse">
+            <a:avLst/>
+          </a:prstGeom>
+          <a:solidFill>
+            <a:schemeClr val="accent2"/>
+          </a:solidFill>
+          <a:ln/>
+        </p:spPr>
+      </p:sp>
+      <p:sp>
+        <p:nvSpPr>
+          <p:cNvPr id="21" name="Text 18"/>
           <p:cNvSpPr txBox="1"/>
           <p:nvPr/>
         </p:nvSpPr>
         <p:spPr>
           <a:xfrm>
-            <a:off x="5989320" y="1554480"/>
-            <a:ext cx="2057400" cy="365760"/>
-          </a:xfrm>
-          <a:prstGeom prst="rect">
-            <a:avLst/>
-          </a:prstGeom>
-          <a:noFill/>
-          <a:ln/>
-        </p:spPr>
-        <p:txBody>
-          <a:bodyPr wrap="square" lIns="0" tIns="0" rIns="0" bIns="0" rtlCol="0" anchor="t"/>
-          <a:lstStyle/>
-          <a:p>
-            <a:pPr indent="0" marL="0">
-              <a:buNone/>
-            </a:pPr>
-            <a:r>
-              <a:rPr lang="en-US" sz="1000" dirty="0">
-                <a:solidFill>
-                  <a:schemeClr val="accent5"/>
-                </a:solidFill>
-              </a:rPr>
-              <a:t>Nguyễn Văn A · GĐ2 · Buổi 3 · Lớp Z-07 (15/10 08:00)</a:t>
-            </a:r>
-            <a:endParaRPr lang="en-US" sz="1000" dirty="0"/>
-          </a:p>
-        </p:txBody>
-      </p:sp>
-      <p:sp>
-        <p:nvSpPr>
-          <p:cNvPr id="22" name="Chon trang thai"/>
+            <a:off x="6300216" y="2260397"/>
+            <a:ext cx="292608" cy="292608"/>
+          </a:xfrm>
+          <a:prstGeom prst="rect">
+            <a:avLst/>
+          </a:prstGeom>
+          <a:noFill/>
+          <a:ln/>
+        </p:spPr>
+        <p:txBody>
+          <a:bodyPr wrap="square" lIns="0" tIns="0" rIns="0" bIns="0" rtlCol="0" anchor="ctr"/>
+          <a:lstStyle/>
+          <a:p>
+            <a:pPr algn="ctr" indent="0" marL="0">
+              <a:buNone/>
+            </a:pPr>
+            <a:r>
+              <a:rPr lang="en-US" sz="1300" b="1" dirty="0">
+                <a:solidFill>
+                  <a:schemeClr val="bg1"/>
+                </a:solidFill>
+              </a:rPr>
+              <a:t>2</a:t>
+            </a:r>
+            <a:endParaRPr lang="en-US" sz="1300" dirty="0"/>
+          </a:p>
+        </p:txBody>
+      </p:sp>
+      <p:sp>
+        <p:nvSpPr>
+          <p:cNvPr id="22" name="So 3"/>
           <p:cNvSpPr/>
           <p:nvPr/>
         </p:nvSpPr>
         <p:spPr>
           <a:xfrm>
-            <a:off x="5989320" y="1984248"/>
-            <a:ext cx="2057400" cy="310896"/>
-          </a:xfrm>
-          <a:prstGeom prst="roundRect">
-            <a:avLst>
-              <a:gd name="adj" fmla="val 17647"/>
-            </a:avLst>
+            <a:off x="6300216" y="3198571"/>
+            <a:ext cx="292608" cy="292608"/>
+          </a:xfrm>
+          <a:prstGeom prst="ellipse">
+            <a:avLst/>
           </a:prstGeom>
           <a:solidFill>
-            <a:schemeClr val="bg2"/>
+            <a:schemeClr val="accent2"/>
           </a:solidFill>
           <a:ln/>
         </p:spPr>
       </p:sp>
       <p:sp>
         <p:nvSpPr>
-          <p:cNvPr id="23" name="Co mat chon"/>
+          <p:cNvPr id="23" name="Text 20"/>
+          <p:cNvSpPr txBox="1"/>
+          <p:nvPr/>
+        </p:nvSpPr>
+        <p:spPr>
+          <a:xfrm>
+            <a:off x="6300216" y="3198571"/>
+            <a:ext cx="292608" cy="292608"/>
+          </a:xfrm>
+          <a:prstGeom prst="rect">
+            <a:avLst/>
+          </a:prstGeom>
+          <a:noFill/>
+          <a:ln/>
+        </p:spPr>
+        <p:txBody>
+          <a:bodyPr wrap="square" lIns="0" tIns="0" rIns="0" bIns="0" rtlCol="0" anchor="ctr"/>
+          <a:lstStyle/>
+          <a:p>
+            <a:pPr algn="ctr" indent="0" marL="0">
+              <a:buNone/>
+            </a:pPr>
+            <a:r>
+              <a:rPr lang="en-US" sz="1300" b="1" dirty="0">
+                <a:solidFill>
+                  <a:schemeClr val="bg1"/>
+                </a:solidFill>
+              </a:rPr>
+              <a:t>3</a:t>
+            </a:r>
+            <a:endParaRPr lang="en-US" sz="1300" dirty="0"/>
+          </a:p>
+        </p:txBody>
+      </p:sp>
+      <p:sp>
+        <p:nvSpPr>
+          <p:cNvPr id="24" name="So 4"/>
           <p:cNvSpPr/>
           <p:nvPr/>
         </p:nvSpPr>
         <p:spPr>
           <a:xfrm>
-            <a:off x="6016752" y="2011680"/>
-            <a:ext cx="1001268" cy="256032"/>
-          </a:xfrm>
-          <a:prstGeom prst="roundRect">
-            <a:avLst>
-              <a:gd name="adj" fmla="val 17857"/>
-            </a:avLst>
+            <a:off x="6300216" y="4067251"/>
+            <a:ext cx="292608" cy="292608"/>
+          </a:xfrm>
+          <a:prstGeom prst="ellipse">
+            <a:avLst/>
           </a:prstGeom>
           <a:solidFill>
-            <a:schemeClr val="bg1"/>
+            <a:schemeClr val="accent2"/>
           </a:solidFill>
-          <a:ln w="12700">
-            <a:solidFill>
-              <a:schemeClr val="accent1"/>
-            </a:solidFill>
-            <a:prstDash val="solid"/>
-          </a:ln>
-        </p:spPr>
-      </p:sp>
-      <p:sp>
-        <p:nvSpPr>
-          <p:cNvPr id="24" name="Text 22"/>
+          <a:ln/>
+        </p:spPr>
+      </p:sp>
+      <p:sp>
+        <p:nvSpPr>
+          <p:cNvPr id="25" name="Text 22"/>
           <p:cNvSpPr txBox="1"/>
           <p:nvPr/>
         </p:nvSpPr>
         <p:spPr>
           <a:xfrm>
-            <a:off x="5989320" y="1984248"/>
-            <a:ext cx="1028700" cy="310896"/>
+            <a:off x="6300216" y="4067251"/>
+            <a:ext cx="292608" cy="292608"/>
           </a:xfrm>
           <a:prstGeom prst="rect">
             <a:avLst/>
@@ -5459,330 +5061,14 @@
               <a:buNone/>
             </a:pPr>
             <a:r>
-              <a:rPr lang="en-US" sz="1000" b="1" dirty="0">
-                <a:solidFill>
-                  <a:schemeClr val="accent1"/>
-                </a:solidFill>
-              </a:rPr>
-              <a:t>Có mặt</a:t>
-            </a:r>
-            <a:endParaRPr lang="en-US" sz="1000" dirty="0"/>
-          </a:p>
-        </p:txBody>
-      </p:sp>
-      <p:sp>
-        <p:nvSpPr>
-          <p:cNvPr id="25" name="Text 23"/>
-          <p:cNvSpPr txBox="1"/>
-          <p:nvPr/>
-        </p:nvSpPr>
-        <p:spPr>
-          <a:xfrm>
-            <a:off x="7018020" y="1984248"/>
-            <a:ext cx="1028700" cy="310896"/>
-          </a:xfrm>
-          <a:prstGeom prst="rect">
-            <a:avLst/>
-          </a:prstGeom>
-          <a:noFill/>
-          <a:ln/>
-        </p:spPr>
-        <p:txBody>
-          <a:bodyPr wrap="square" lIns="0" tIns="0" rIns="0" bIns="0" rtlCol="0" anchor="ctr"/>
-          <a:lstStyle/>
-          <a:p>
-            <a:pPr algn="ctr" indent="0" marL="0">
-              <a:buNone/>
-            </a:pPr>
-            <a:r>
-              <a:rPr lang="en-US" sz="1000" dirty="0">
-                <a:solidFill>
-                  <a:schemeClr val="accent5"/>
-                </a:solidFill>
-              </a:rPr>
-              <a:t>Vắng có phép</a:t>
-            </a:r>
-            <a:endParaRPr lang="en-US" sz="1000" dirty="0"/>
-          </a:p>
-        </p:txBody>
-      </p:sp>
-      <p:sp>
-        <p:nvSpPr>
-          <p:cNvPr id="26" name="Text 24"/>
-          <p:cNvSpPr txBox="1"/>
-          <p:nvPr/>
-        </p:nvSpPr>
-        <p:spPr>
-          <a:xfrm>
-            <a:off x="5989320" y="2377440"/>
-            <a:ext cx="2057400" cy="201168"/>
-          </a:xfrm>
-          <a:prstGeom prst="rect">
-            <a:avLst/>
-          </a:prstGeom>
-          <a:noFill/>
-          <a:ln/>
-        </p:spPr>
-        <p:txBody>
-          <a:bodyPr wrap="square" lIns="0" tIns="0" rIns="0" bIns="0" rtlCol="0" anchor="ctr"/>
-          <a:lstStyle/>
-          <a:p>
-            <a:pPr indent="0" marL="0">
-              <a:buNone/>
-            </a:pPr>
-            <a:r>
-              <a:rPr lang="en-US" sz="1000" b="1" dirty="0">
-                <a:solidFill>
-                  <a:schemeClr val="tx1"/>
-                </a:solidFill>
-              </a:rPr>
-              <a:t>Lý do *</a:t>
-            </a:r>
-            <a:endParaRPr lang="en-US" sz="1000" dirty="0"/>
-          </a:p>
-        </p:txBody>
-      </p:sp>
-      <p:sp>
-        <p:nvSpPr>
-          <p:cNvPr id="27" name="O ly do"/>
-          <p:cNvSpPr/>
-          <p:nvPr/>
-        </p:nvSpPr>
-        <p:spPr>
-          <a:xfrm>
-            <a:off x="5989320" y="2596896"/>
-            <a:ext cx="2057400" cy="566928"/>
-          </a:xfrm>
-          <a:prstGeom prst="roundRect">
-            <a:avLst>
-              <a:gd name="adj" fmla="val 8065"/>
-            </a:avLst>
-          </a:prstGeom>
-          <a:solidFill>
-            <a:schemeClr val="bg1"/>
-          </a:solidFill>
-          <a:ln w="9525">
-            <a:solidFill>
-              <a:schemeClr val="accent5"/>
-            </a:solidFill>
-            <a:prstDash val="solid"/>
-          </a:ln>
-        </p:spPr>
-      </p:sp>
-      <p:sp>
-        <p:nvSpPr>
-          <p:cNvPr id="28" name="Text 26"/>
-          <p:cNvSpPr txBox="1"/>
-          <p:nvPr/>
-        </p:nvSpPr>
-        <p:spPr>
-          <a:xfrm>
-            <a:off x="6044184" y="2624328"/>
-            <a:ext cx="1947672" cy="512064"/>
-          </a:xfrm>
-          <a:prstGeom prst="rect">
-            <a:avLst/>
-          </a:prstGeom>
-          <a:noFill/>
-          <a:ln/>
-        </p:spPr>
-        <p:txBody>
-          <a:bodyPr wrap="square" lIns="0" tIns="0" rIns="0" bIns="0" rtlCol="0" anchor="t"/>
-          <a:lstStyle/>
-          <a:p>
-            <a:pPr indent="0" marL="0">
-              <a:buNone/>
-            </a:pPr>
-            <a:r>
-              <a:rPr lang="en-US" sz="1000" dirty="0">
-                <a:solidFill>
-                  <a:schemeClr val="tx1"/>
-                </a:solidFill>
-              </a:rPr>
-              <a:t>Ảnh Zoom 08:05 có tên HV, gửi qua Zalo 19/10</a:t>
-            </a:r>
-            <a:endParaRPr lang="en-US" sz="1000" dirty="0"/>
-          </a:p>
-        </p:txBody>
-      </p:sp>
-      <p:sp>
-        <p:nvSpPr>
-          <p:cNvPr id="29" name="Canh bao"/>
-          <p:cNvSpPr/>
-          <p:nvPr/>
-        </p:nvSpPr>
-        <p:spPr>
-          <a:xfrm>
-            <a:off x="5989320" y="3255264"/>
-            <a:ext cx="2057400" cy="566928"/>
-          </a:xfrm>
-          <a:prstGeom prst="roundRect">
-            <a:avLst>
-              <a:gd name="adj" fmla="val 8065"/>
-            </a:avLst>
-          </a:prstGeom>
-          <a:solidFill>
-            <a:schemeClr val="accent2">
-              <a:alpha val="20000"/>
-            </a:schemeClr>
-          </a:solidFill>
-          <a:ln/>
-        </p:spPr>
-      </p:sp>
-      <p:sp>
-        <p:nvSpPr>
-          <p:cNvPr id="30" name="Text 28"/>
-          <p:cNvSpPr txBox="1"/>
-          <p:nvPr/>
-        </p:nvSpPr>
-        <p:spPr>
-          <a:xfrm>
-            <a:off x="6044184" y="3273552"/>
-            <a:ext cx="1947672" cy="530352"/>
-          </a:xfrm>
-          <a:prstGeom prst="rect">
-            <a:avLst/>
-          </a:prstGeom>
-          <a:noFill/>
-          <a:ln/>
-        </p:spPr>
-        <p:txBody>
-          <a:bodyPr wrap="square" lIns="0" tIns="0" rIns="0" bIns="0" rtlCol="0" anchor="ctr"/>
-          <a:lstStyle/>
-          <a:p>
-            <a:pPr indent="0" marL="0">
-              <a:buNone/>
-            </a:pPr>
-            <a:r>
-              <a:rPr lang="en-US" sz="1000" dirty="0">
-                <a:solidFill>
-                  <a:schemeClr val="tx1"/>
-                </a:solidFill>
-              </a:rPr>
-              <a:t>Nếu Quản trị nạp lại file điểm danh của buổi này, kết quả bổ sung sẽ bị ghi đè.</a:t>
-            </a:r>
-            <a:endParaRPr lang="en-US" sz="1000" dirty="0"/>
-          </a:p>
-        </p:txBody>
-      </p:sp>
-      <p:sp>
-        <p:nvSpPr>
-          <p:cNvPr id="31" name="Nut huy"/>
-          <p:cNvSpPr/>
-          <p:nvPr/>
-        </p:nvSpPr>
-        <p:spPr>
-          <a:xfrm>
-            <a:off x="6446520" y="3977640"/>
-            <a:ext cx="685800" cy="292608"/>
-          </a:xfrm>
-          <a:prstGeom prst="roundRect">
-            <a:avLst>
-              <a:gd name="adj" fmla="val 15625"/>
-            </a:avLst>
-          </a:prstGeom>
-          <a:solidFill>
-            <a:schemeClr val="bg1"/>
-          </a:solidFill>
-          <a:ln w="9525">
-            <a:solidFill>
-              <a:schemeClr val="accent5"/>
-            </a:solidFill>
-            <a:prstDash val="solid"/>
-          </a:ln>
-        </p:spPr>
-      </p:sp>
-      <p:sp>
-        <p:nvSpPr>
-          <p:cNvPr id="32" name="Text 30"/>
-          <p:cNvSpPr txBox="1"/>
-          <p:nvPr/>
-        </p:nvSpPr>
-        <p:spPr>
-          <a:xfrm>
-            <a:off x="6446520" y="3977640"/>
-            <a:ext cx="685800" cy="292608"/>
-          </a:xfrm>
-          <a:prstGeom prst="rect">
-            <a:avLst/>
-          </a:prstGeom>
-          <a:noFill/>
-          <a:ln/>
-        </p:spPr>
-        <p:txBody>
-          <a:bodyPr wrap="square" lIns="0" tIns="0" rIns="0" bIns="0" rtlCol="0" anchor="ctr"/>
-          <a:lstStyle/>
-          <a:p>
-            <a:pPr algn="ctr" indent="0" marL="0">
-              <a:buNone/>
-            </a:pPr>
-            <a:r>
-              <a:rPr lang="en-US" sz="1000" dirty="0">
-                <a:solidFill>
-                  <a:schemeClr val="tx1"/>
-                </a:solidFill>
-              </a:rPr>
-              <a:t>Hủy</a:t>
-            </a:r>
-            <a:endParaRPr lang="en-US" sz="1000" dirty="0"/>
-          </a:p>
-        </p:txBody>
-      </p:sp>
-      <p:sp>
-        <p:nvSpPr>
-          <p:cNvPr id="33" name="Nut xac nhan"/>
-          <p:cNvSpPr/>
-          <p:nvPr/>
-        </p:nvSpPr>
-        <p:spPr>
-          <a:xfrm>
-            <a:off x="7223760" y="3977640"/>
-            <a:ext cx="822960" cy="292608"/>
-          </a:xfrm>
-          <a:prstGeom prst="roundRect">
-            <a:avLst>
-              <a:gd name="adj" fmla="val 15625"/>
-            </a:avLst>
-          </a:prstGeom>
-          <a:solidFill>
-            <a:schemeClr val="tx2"/>
-          </a:solidFill>
-          <a:ln/>
-        </p:spPr>
-      </p:sp>
-      <p:sp>
-        <p:nvSpPr>
-          <p:cNvPr id="34" name="Text 32"/>
-          <p:cNvSpPr txBox="1"/>
-          <p:nvPr/>
-        </p:nvSpPr>
-        <p:spPr>
-          <a:xfrm>
-            <a:off x="7223760" y="3977640"/>
-            <a:ext cx="822960" cy="292608"/>
-          </a:xfrm>
-          <a:prstGeom prst="rect">
-            <a:avLst/>
-          </a:prstGeom>
-          <a:noFill/>
-          <a:ln/>
-        </p:spPr>
-        <p:txBody>
-          <a:bodyPr wrap="square" lIns="0" tIns="0" rIns="0" bIns="0" rtlCol="0" anchor="ctr"/>
-          <a:lstStyle/>
-          <a:p>
-            <a:pPr algn="ctr" indent="0" marL="0">
-              <a:buNone/>
-            </a:pPr>
-            <a:r>
-              <a:rPr lang="en-US" sz="1000" b="1" dirty="0">
+              <a:rPr lang="en-US" sz="1300" b="1" dirty="0">
                 <a:solidFill>
                   <a:schemeClr val="bg1"/>
                 </a:solidFill>
               </a:rPr>
-              <a:t>Xác nhận</a:t>
-            </a:r>
-            <a:endParaRPr lang="en-US" sz="1000" dirty="0"/>
+              <a:t>4</a:t>
+            </a:r>
+            <a:endParaRPr lang="en-US" sz="1300" dirty="0"/>
           </a:p>
         </p:txBody>
       </p:sp>
@@ -5888,6 +5174,1505 @@
                   <a:schemeClr val="tx2"/>
                 </a:solidFill>
               </a:rPr>
+              <a:t>Ghi điểm danh bổ sung</a:t>
+            </a:r>
+            <a:endParaRPr lang="en-US" sz="2800" dirty="0"/>
+          </a:p>
+        </p:txBody>
+      </p:sp>
+      <p:sp>
+        <p:nvSpPr>
+          <p:cNvPr id="3" name="So 1"/>
+          <p:cNvSpPr/>
+          <p:nvPr/>
+        </p:nvSpPr>
+        <p:spPr>
+          <a:xfrm>
+            <a:off x="457200" y="1143000"/>
+            <a:ext cx="365760" cy="365760"/>
+          </a:xfrm>
+          <a:prstGeom prst="ellipse">
+            <a:avLst/>
+          </a:prstGeom>
+          <a:solidFill>
+            <a:schemeClr val="tx2"/>
+          </a:solidFill>
+          <a:ln/>
+        </p:spPr>
+      </p:sp>
+      <p:sp>
+        <p:nvSpPr>
+          <p:cNvPr id="4" name="Text 2"/>
+          <p:cNvSpPr txBox="1"/>
+          <p:nvPr/>
+        </p:nvSpPr>
+        <p:spPr>
+          <a:xfrm>
+            <a:off x="457200" y="1143000"/>
+            <a:ext cx="365760" cy="365760"/>
+          </a:xfrm>
+          <a:prstGeom prst="rect">
+            <a:avLst/>
+          </a:prstGeom>
+          <a:noFill/>
+          <a:ln/>
+        </p:spPr>
+        <p:txBody>
+          <a:bodyPr wrap="square" lIns="0" tIns="0" rIns="0" bIns="0" rtlCol="0" anchor="ctr"/>
+          <a:lstStyle/>
+          <a:p>
+            <a:pPr algn="ctr" indent="0" marL="0">
+              <a:buNone/>
+            </a:pPr>
+            <a:r>
+              <a:rPr lang="en-US" sz="1600" b="1" dirty="0">
+                <a:solidFill>
+                  <a:schemeClr val="bg1"/>
+                </a:solidFill>
+              </a:rPr>
+              <a:t>1</a:t>
+            </a:r>
+            <a:endParaRPr lang="en-US" sz="1600" dirty="0"/>
+          </a:p>
+        </p:txBody>
+      </p:sp>
+      <p:sp>
+        <p:nvSpPr>
+          <p:cNvPr id="5" name="Text 3"/>
+          <p:cNvSpPr txBox="1"/>
+          <p:nvPr/>
+        </p:nvSpPr>
+        <p:spPr>
+          <a:xfrm>
+            <a:off x="960120" y="1106424"/>
+            <a:ext cx="3520440" cy="585216"/>
+          </a:xfrm>
+          <a:prstGeom prst="rect">
+            <a:avLst/>
+          </a:prstGeom>
+          <a:noFill/>
+          <a:ln/>
+        </p:spPr>
+        <p:txBody>
+          <a:bodyPr wrap="square" lIns="0" tIns="0" rIns="0" bIns="0" rtlCol="0" anchor="t"/>
+          <a:lstStyle/>
+          <a:p>
+            <a:pPr indent="0" marL="0">
+              <a:buNone/>
+            </a:pPr>
+            <a:r>
+              <a:rPr lang="en-US" sz="1400" dirty="0">
+                <a:solidFill>
+                  <a:schemeClr val="tx1"/>
+                </a:solidFill>
+              </a:rPr>
+              <a:t>Tìm đúng buổi: </a:t>
+            </a:r>
+            <a:pPr indent="0" marL="0">
+              <a:buNone/>
+            </a:pPr>
+            <a:r>
+              <a:rPr lang="en-US" sz="1400" b="1" dirty="0">
+                <a:solidFill>
+                  <a:schemeClr val="tx1"/>
+                </a:solidFill>
+              </a:rPr>
+              <a:t>GĐ · Buổi · Lớp · giờ</a:t>
+            </a:r>
+            <a:endParaRPr lang="en-US" sz="1400" dirty="0"/>
+          </a:p>
+        </p:txBody>
+      </p:sp>
+      <p:sp>
+        <p:nvSpPr>
+          <p:cNvPr id="6" name="So 2"/>
+          <p:cNvSpPr/>
+          <p:nvPr/>
+        </p:nvSpPr>
+        <p:spPr>
+          <a:xfrm>
+            <a:off x="457200" y="1783080"/>
+            <a:ext cx="365760" cy="365760"/>
+          </a:xfrm>
+          <a:prstGeom prst="ellipse">
+            <a:avLst/>
+          </a:prstGeom>
+          <a:solidFill>
+            <a:schemeClr val="tx2"/>
+          </a:solidFill>
+          <a:ln/>
+        </p:spPr>
+      </p:sp>
+      <p:sp>
+        <p:nvSpPr>
+          <p:cNvPr id="7" name="Text 5"/>
+          <p:cNvSpPr txBox="1"/>
+          <p:nvPr/>
+        </p:nvSpPr>
+        <p:spPr>
+          <a:xfrm>
+            <a:off x="457200" y="1783080"/>
+            <a:ext cx="365760" cy="365760"/>
+          </a:xfrm>
+          <a:prstGeom prst="rect">
+            <a:avLst/>
+          </a:prstGeom>
+          <a:noFill/>
+          <a:ln/>
+        </p:spPr>
+        <p:txBody>
+          <a:bodyPr wrap="square" lIns="0" tIns="0" rIns="0" bIns="0" rtlCol="0" anchor="ctr"/>
+          <a:lstStyle/>
+          <a:p>
+            <a:pPr algn="ctr" indent="0" marL="0">
+              <a:buNone/>
+            </a:pPr>
+            <a:r>
+              <a:rPr lang="en-US" sz="1600" b="1" dirty="0">
+                <a:solidFill>
+                  <a:schemeClr val="bg1"/>
+                </a:solidFill>
+              </a:rPr>
+              <a:t>2</a:t>
+            </a:r>
+            <a:endParaRPr lang="en-US" sz="1600" dirty="0"/>
+          </a:p>
+        </p:txBody>
+      </p:sp>
+      <p:sp>
+        <p:nvSpPr>
+          <p:cNvPr id="8" name="Text 6"/>
+          <p:cNvSpPr txBox="1"/>
+          <p:nvPr/>
+        </p:nvSpPr>
+        <p:spPr>
+          <a:xfrm>
+            <a:off x="960120" y="1746504"/>
+            <a:ext cx="3520440" cy="585216"/>
+          </a:xfrm>
+          <a:prstGeom prst="rect">
+            <a:avLst/>
+          </a:prstGeom>
+          <a:noFill/>
+          <a:ln/>
+        </p:spPr>
+        <p:txBody>
+          <a:bodyPr wrap="square" lIns="0" tIns="0" rIns="0" bIns="0" rtlCol="0" anchor="t"/>
+          <a:lstStyle/>
+          <a:p>
+            <a:pPr indent="0" marL="0">
+              <a:buNone/>
+            </a:pPr>
+            <a:r>
+              <a:rPr lang="en-US" sz="1400" dirty="0">
+                <a:solidFill>
+                  <a:schemeClr val="tx1"/>
+                </a:solidFill>
+              </a:rPr>
+              <a:t>Bấm </a:t>
+            </a:r>
+            <a:pPr indent="0" marL="0">
+              <a:buNone/>
+            </a:pPr>
+            <a:r>
+              <a:rPr lang="en-US" sz="1400" b="1" dirty="0">
+                <a:solidFill>
+                  <a:schemeClr val="tx1"/>
+                </a:solidFill>
+              </a:rPr>
+              <a:t>Điểm danh bổ sung</a:t>
+            </a:r>
+            <a:endParaRPr lang="en-US" sz="1400" dirty="0"/>
+          </a:p>
+        </p:txBody>
+      </p:sp>
+      <p:sp>
+        <p:nvSpPr>
+          <p:cNvPr id="9" name="So 3"/>
+          <p:cNvSpPr/>
+          <p:nvPr/>
+        </p:nvSpPr>
+        <p:spPr>
+          <a:xfrm>
+            <a:off x="457200" y="2423160"/>
+            <a:ext cx="365760" cy="365760"/>
+          </a:xfrm>
+          <a:prstGeom prst="ellipse">
+            <a:avLst/>
+          </a:prstGeom>
+          <a:solidFill>
+            <a:schemeClr val="tx2"/>
+          </a:solidFill>
+          <a:ln/>
+        </p:spPr>
+      </p:sp>
+      <p:sp>
+        <p:nvSpPr>
+          <p:cNvPr id="10" name="Text 8"/>
+          <p:cNvSpPr txBox="1"/>
+          <p:nvPr/>
+        </p:nvSpPr>
+        <p:spPr>
+          <a:xfrm>
+            <a:off x="457200" y="2423160"/>
+            <a:ext cx="365760" cy="365760"/>
+          </a:xfrm>
+          <a:prstGeom prst="rect">
+            <a:avLst/>
+          </a:prstGeom>
+          <a:noFill/>
+          <a:ln/>
+        </p:spPr>
+        <p:txBody>
+          <a:bodyPr wrap="square" lIns="0" tIns="0" rIns="0" bIns="0" rtlCol="0" anchor="ctr"/>
+          <a:lstStyle/>
+          <a:p>
+            <a:pPr algn="ctr" indent="0" marL="0">
+              <a:buNone/>
+            </a:pPr>
+            <a:r>
+              <a:rPr lang="en-US" sz="1600" b="1" dirty="0">
+                <a:solidFill>
+                  <a:schemeClr val="bg1"/>
+                </a:solidFill>
+              </a:rPr>
+              <a:t>3</a:t>
+            </a:r>
+            <a:endParaRPr lang="en-US" sz="1600" dirty="0"/>
+          </a:p>
+        </p:txBody>
+      </p:sp>
+      <p:sp>
+        <p:nvSpPr>
+          <p:cNvPr id="11" name="Text 9"/>
+          <p:cNvSpPr txBox="1"/>
+          <p:nvPr/>
+        </p:nvSpPr>
+        <p:spPr>
+          <a:xfrm>
+            <a:off x="960120" y="2386584"/>
+            <a:ext cx="3520440" cy="585216"/>
+          </a:xfrm>
+          <a:prstGeom prst="rect">
+            <a:avLst/>
+          </a:prstGeom>
+          <a:noFill/>
+          <a:ln/>
+        </p:spPr>
+        <p:txBody>
+          <a:bodyPr wrap="square" lIns="0" tIns="0" rIns="0" bIns="0" rtlCol="0" anchor="t"/>
+          <a:lstStyle/>
+          <a:p>
+            <a:pPr indent="0" marL="0">
+              <a:buNone/>
+            </a:pPr>
+            <a:r>
+              <a:rPr lang="en-US" sz="1400" dirty="0">
+                <a:solidFill>
+                  <a:schemeClr val="tx1"/>
+                </a:solidFill>
+              </a:rPr>
+              <a:t>Chọn </a:t>
+            </a:r>
+            <a:pPr indent="0" marL="0">
+              <a:buNone/>
+            </a:pPr>
+            <a:r>
+              <a:rPr lang="en-US" sz="1400" b="1" dirty="0">
+                <a:solidFill>
+                  <a:schemeClr val="accent1"/>
+                </a:solidFill>
+              </a:rPr>
+              <a:t>Có mặt</a:t>
+            </a:r>
+            <a:pPr indent="0" marL="0">
+              <a:buNone/>
+            </a:pPr>
+            <a:r>
+              <a:rPr lang="en-US" sz="1400" dirty="0">
+                <a:solidFill>
+                  <a:schemeClr val="tx1"/>
+                </a:solidFill>
+              </a:rPr>
+              <a:t> hoặc </a:t>
+            </a:r>
+            <a:pPr indent="0" marL="0">
+              <a:buNone/>
+            </a:pPr>
+            <a:r>
+              <a:rPr lang="en-US" sz="1400" b="1" dirty="0">
+                <a:solidFill>
+                  <a:schemeClr val="accent2"/>
+                </a:solidFill>
+              </a:rPr>
+              <a:t>Vắng có phép</a:t>
+            </a:r>
+            <a:endParaRPr lang="en-US" sz="1400" dirty="0"/>
+          </a:p>
+        </p:txBody>
+      </p:sp>
+      <p:sp>
+        <p:nvSpPr>
+          <p:cNvPr id="12" name="So 4"/>
+          <p:cNvSpPr/>
+          <p:nvPr/>
+        </p:nvSpPr>
+        <p:spPr>
+          <a:xfrm>
+            <a:off x="457200" y="3063240"/>
+            <a:ext cx="365760" cy="365760"/>
+          </a:xfrm>
+          <a:prstGeom prst="ellipse">
+            <a:avLst/>
+          </a:prstGeom>
+          <a:solidFill>
+            <a:schemeClr val="tx2"/>
+          </a:solidFill>
+          <a:ln/>
+        </p:spPr>
+      </p:sp>
+      <p:sp>
+        <p:nvSpPr>
+          <p:cNvPr id="13" name="Text 11"/>
+          <p:cNvSpPr txBox="1"/>
+          <p:nvPr/>
+        </p:nvSpPr>
+        <p:spPr>
+          <a:xfrm>
+            <a:off x="457200" y="3063240"/>
+            <a:ext cx="365760" cy="365760"/>
+          </a:xfrm>
+          <a:prstGeom prst="rect">
+            <a:avLst/>
+          </a:prstGeom>
+          <a:noFill/>
+          <a:ln/>
+        </p:spPr>
+        <p:txBody>
+          <a:bodyPr wrap="square" lIns="0" tIns="0" rIns="0" bIns="0" rtlCol="0" anchor="ctr"/>
+          <a:lstStyle/>
+          <a:p>
+            <a:pPr algn="ctr" indent="0" marL="0">
+              <a:buNone/>
+            </a:pPr>
+            <a:r>
+              <a:rPr lang="en-US" sz="1600" b="1" dirty="0">
+                <a:solidFill>
+                  <a:schemeClr val="bg1"/>
+                </a:solidFill>
+              </a:rPr>
+              <a:t>4</a:t>
+            </a:r>
+            <a:endParaRPr lang="en-US" sz="1600" dirty="0"/>
+          </a:p>
+        </p:txBody>
+      </p:sp>
+      <p:sp>
+        <p:nvSpPr>
+          <p:cNvPr id="14" name="Text 12"/>
+          <p:cNvSpPr txBox="1"/>
+          <p:nvPr/>
+        </p:nvSpPr>
+        <p:spPr>
+          <a:xfrm>
+            <a:off x="960120" y="3026664"/>
+            <a:ext cx="3520440" cy="585216"/>
+          </a:xfrm>
+          <a:prstGeom prst="rect">
+            <a:avLst/>
+          </a:prstGeom>
+          <a:noFill/>
+          <a:ln/>
+        </p:spPr>
+        <p:txBody>
+          <a:bodyPr wrap="square" lIns="0" tIns="0" rIns="0" bIns="0" rtlCol="0" anchor="t"/>
+          <a:lstStyle/>
+          <a:p>
+            <a:pPr indent="0" marL="0">
+              <a:buNone/>
+            </a:pPr>
+            <a:r>
+              <a:rPr lang="en-US" sz="1400" dirty="0">
+                <a:solidFill>
+                  <a:schemeClr val="tx1"/>
+                </a:solidFill>
+              </a:rPr>
+              <a:t>Nhập </a:t>
+            </a:r>
+            <a:pPr indent="0" marL="0">
+              <a:buNone/>
+            </a:pPr>
+            <a:r>
+              <a:rPr lang="en-US" sz="1400" b="1" dirty="0">
+                <a:solidFill>
+                  <a:schemeClr val="tx1"/>
+                </a:solidFill>
+              </a:rPr>
+              <a:t>Lý do</a:t>
+            </a:r>
+            <a:pPr indent="0" marL="0">
+              <a:buNone/>
+            </a:pPr>
+            <a:r>
+              <a:rPr lang="en-US" sz="1400" dirty="0">
+                <a:solidFill>
+                  <a:schemeClr val="tx1"/>
+                </a:solidFill>
+              </a:rPr>
+              <a:t> – minh chứng gì, nhận ở đâu</a:t>
+            </a:r>
+            <a:endParaRPr lang="en-US" sz="1400" dirty="0"/>
+          </a:p>
+        </p:txBody>
+      </p:sp>
+      <p:sp>
+        <p:nvSpPr>
+          <p:cNvPr id="15" name="So 5"/>
+          <p:cNvSpPr/>
+          <p:nvPr/>
+        </p:nvSpPr>
+        <p:spPr>
+          <a:xfrm>
+            <a:off x="457200" y="3703320"/>
+            <a:ext cx="365760" cy="365760"/>
+          </a:xfrm>
+          <a:prstGeom prst="ellipse">
+            <a:avLst/>
+          </a:prstGeom>
+          <a:solidFill>
+            <a:schemeClr val="tx2"/>
+          </a:solidFill>
+          <a:ln/>
+        </p:spPr>
+      </p:sp>
+      <p:sp>
+        <p:nvSpPr>
+          <p:cNvPr id="16" name="Text 14"/>
+          <p:cNvSpPr txBox="1"/>
+          <p:nvPr/>
+        </p:nvSpPr>
+        <p:spPr>
+          <a:xfrm>
+            <a:off x="457200" y="3703320"/>
+            <a:ext cx="365760" cy="365760"/>
+          </a:xfrm>
+          <a:prstGeom prst="rect">
+            <a:avLst/>
+          </a:prstGeom>
+          <a:noFill/>
+          <a:ln/>
+        </p:spPr>
+        <p:txBody>
+          <a:bodyPr wrap="square" lIns="0" tIns="0" rIns="0" bIns="0" rtlCol="0" anchor="ctr"/>
+          <a:lstStyle/>
+          <a:p>
+            <a:pPr algn="ctr" indent="0" marL="0">
+              <a:buNone/>
+            </a:pPr>
+            <a:r>
+              <a:rPr lang="en-US" sz="1600" b="1" dirty="0">
+                <a:solidFill>
+                  <a:schemeClr val="bg1"/>
+                </a:solidFill>
+              </a:rPr>
+              <a:t>5</a:t>
+            </a:r>
+            <a:endParaRPr lang="en-US" sz="1600" dirty="0"/>
+          </a:p>
+        </p:txBody>
+      </p:sp>
+      <p:sp>
+        <p:nvSpPr>
+          <p:cNvPr id="17" name="Text 15"/>
+          <p:cNvSpPr txBox="1"/>
+          <p:nvPr/>
+        </p:nvSpPr>
+        <p:spPr>
+          <a:xfrm>
+            <a:off x="960120" y="3666744"/>
+            <a:ext cx="3520440" cy="585216"/>
+          </a:xfrm>
+          <a:prstGeom prst="rect">
+            <a:avLst/>
+          </a:prstGeom>
+          <a:noFill/>
+          <a:ln/>
+        </p:spPr>
+        <p:txBody>
+          <a:bodyPr wrap="square" lIns="0" tIns="0" rIns="0" bIns="0" rtlCol="0" anchor="t"/>
+          <a:lstStyle/>
+          <a:p>
+            <a:pPr indent="0" marL="0">
+              <a:buNone/>
+            </a:pPr>
+            <a:r>
+              <a:rPr lang="en-US" sz="1400" dirty="0">
+                <a:solidFill>
+                  <a:schemeClr val="tx1"/>
+                </a:solidFill>
+              </a:rPr>
+              <a:t>Bấm </a:t>
+            </a:r>
+            <a:pPr indent="0" marL="0">
+              <a:buNone/>
+            </a:pPr>
+            <a:r>
+              <a:rPr lang="en-US" sz="1400" b="1" dirty="0">
+                <a:solidFill>
+                  <a:schemeClr val="tx1"/>
+                </a:solidFill>
+              </a:rPr>
+              <a:t>Xác nhận</a:t>
+            </a:r>
+            <a:endParaRPr lang="en-US" sz="1400" dirty="0"/>
+          </a:p>
+        </p:txBody>
+      </p:sp>
+      <p:sp>
+        <p:nvSpPr>
+          <p:cNvPr id="18" name="Khung ht-chi-tiet"/>
+          <p:cNvSpPr/>
+          <p:nvPr/>
+        </p:nvSpPr>
+        <p:spPr>
+          <a:xfrm>
+            <a:off x="4782312" y="1033272"/>
+            <a:ext cx="1911096" cy="3008376"/>
+          </a:xfrm>
+          <a:prstGeom prst="roundRect">
+            <a:avLst>
+              <a:gd name="adj" fmla="val 5742"/>
+            </a:avLst>
+          </a:prstGeom>
+          <a:solidFill>
+            <a:schemeClr val="tx1"/>
+          </a:solidFill>
+          <a:ln/>
+          <a:effectLst>
+            <a:outerShdw sx="100000" sy="100000" kx="0" ky="0" algn="bl" rotWithShape="0" blurRad="76200" dist="25400" dir="5400000">
+              <a:srgbClr val="1B2A2F">
+                <a:alpha val="25000"/>
+              </a:srgbClr>
+            </a:outerShdw>
+          </a:effectLst>
+        </p:spPr>
+      </p:sp>
+      <p:pic>
+        <p:nvPicPr>
+          <p:cNvPr id="19" name="Anh ht-chi-tiet" descr="Chi tiết từng buổi của học viên, mỗi buổi có nút Điểm danh bổ sung">    </p:cNvPr>
+          <p:cNvPicPr>
+            <a:picLocks noChangeAspect="1"/>
+          </p:cNvPicPr>
+          <p:nvPr/>
+        </p:nvPicPr>
+        <p:blipFill>
+          <a:blip r:embed="rId1"/>
+          <a:stretch>
+            <a:fillRect/>
+          </a:stretch>
+        </p:blipFill>
+        <p:spPr>
+          <a:xfrm>
+            <a:off x="4846320" y="1097280"/>
+            <a:ext cx="1783080" cy="2880360"/>
+          </a:xfrm>
+          <a:prstGeom prst="rect">
+            <a:avLst/>
+          </a:prstGeom>
+        </p:spPr>
+      </p:pic>
+      <p:sp>
+        <p:nvSpPr>
+          <p:cNvPr id="20" name="So 1"/>
+          <p:cNvSpPr/>
+          <p:nvPr/>
+        </p:nvSpPr>
+        <p:spPr>
+          <a:xfrm>
+            <a:off x="4425696" y="2131924"/>
+            <a:ext cx="292608" cy="292608"/>
+          </a:xfrm>
+          <a:prstGeom prst="ellipse">
+            <a:avLst/>
+          </a:prstGeom>
+          <a:solidFill>
+            <a:schemeClr val="accent2"/>
+          </a:solidFill>
+          <a:ln/>
+        </p:spPr>
+      </p:sp>
+      <p:sp>
+        <p:nvSpPr>
+          <p:cNvPr id="21" name="Text 18"/>
+          <p:cNvSpPr txBox="1"/>
+          <p:nvPr/>
+        </p:nvSpPr>
+        <p:spPr>
+          <a:xfrm>
+            <a:off x="4425696" y="2131924"/>
+            <a:ext cx="292608" cy="292608"/>
+          </a:xfrm>
+          <a:prstGeom prst="rect">
+            <a:avLst/>
+          </a:prstGeom>
+          <a:noFill/>
+          <a:ln/>
+        </p:spPr>
+        <p:txBody>
+          <a:bodyPr wrap="square" lIns="0" tIns="0" rIns="0" bIns="0" rtlCol="0" anchor="ctr"/>
+          <a:lstStyle/>
+          <a:p>
+            <a:pPr algn="ctr" indent="0" marL="0">
+              <a:buNone/>
+            </a:pPr>
+            <a:r>
+              <a:rPr lang="en-US" sz="1300" b="1" dirty="0">
+                <a:solidFill>
+                  <a:schemeClr val="bg1"/>
+                </a:solidFill>
+              </a:rPr>
+              <a:t>1</a:t>
+            </a:r>
+            <a:endParaRPr lang="en-US" sz="1300" dirty="0"/>
+          </a:p>
+        </p:txBody>
+      </p:sp>
+      <p:sp>
+        <p:nvSpPr>
+          <p:cNvPr id="22" name="So 2"/>
+          <p:cNvSpPr/>
+          <p:nvPr/>
+        </p:nvSpPr>
+        <p:spPr>
+          <a:xfrm>
+            <a:off x="4425696" y="2563978"/>
+            <a:ext cx="292608" cy="292608"/>
+          </a:xfrm>
+          <a:prstGeom prst="ellipse">
+            <a:avLst/>
+          </a:prstGeom>
+          <a:solidFill>
+            <a:schemeClr val="accent2"/>
+          </a:solidFill>
+          <a:ln/>
+        </p:spPr>
+      </p:sp>
+      <p:sp>
+        <p:nvSpPr>
+          <p:cNvPr id="23" name="Text 20"/>
+          <p:cNvSpPr txBox="1"/>
+          <p:nvPr/>
+        </p:nvSpPr>
+        <p:spPr>
+          <a:xfrm>
+            <a:off x="4425696" y="2563978"/>
+            <a:ext cx="292608" cy="292608"/>
+          </a:xfrm>
+          <a:prstGeom prst="rect">
+            <a:avLst/>
+          </a:prstGeom>
+          <a:noFill/>
+          <a:ln/>
+        </p:spPr>
+        <p:txBody>
+          <a:bodyPr wrap="square" lIns="0" tIns="0" rIns="0" bIns="0" rtlCol="0" anchor="ctr"/>
+          <a:lstStyle/>
+          <a:p>
+            <a:pPr algn="ctr" indent="0" marL="0">
+              <a:buNone/>
+            </a:pPr>
+            <a:r>
+              <a:rPr lang="en-US" sz="1300" b="1" dirty="0">
+                <a:solidFill>
+                  <a:schemeClr val="bg1"/>
+                </a:solidFill>
+              </a:rPr>
+              <a:t>2</a:t>
+            </a:r>
+            <a:endParaRPr lang="en-US" sz="1300" dirty="0"/>
+          </a:p>
+        </p:txBody>
+      </p:sp>
+      <p:sp>
+        <p:nvSpPr>
+          <p:cNvPr id="24" name="Mui ten"/>
+          <p:cNvSpPr/>
+          <p:nvPr/>
+        </p:nvSpPr>
+        <p:spPr>
+          <a:xfrm>
+            <a:off x="6739128" y="2377440"/>
+            <a:ext cx="228600" cy="274320"/>
+          </a:xfrm>
+          <a:prstGeom prst="rightArrow">
+            <a:avLst/>
+          </a:prstGeom>
+          <a:solidFill>
+            <a:schemeClr val="accent6"/>
+          </a:solidFill>
+          <a:ln/>
+        </p:spPr>
+      </p:sp>
+      <p:sp>
+        <p:nvSpPr>
+          <p:cNvPr id="25" name="Khung ht-modal"/>
+          <p:cNvSpPr/>
+          <p:nvPr/>
+        </p:nvSpPr>
+        <p:spPr>
+          <a:xfrm>
+            <a:off x="7022592" y="1536192"/>
+            <a:ext cx="1591056" cy="1729452"/>
+          </a:xfrm>
+          <a:prstGeom prst="roundRect">
+            <a:avLst>
+              <a:gd name="adj" fmla="val 6897"/>
+            </a:avLst>
+          </a:prstGeom>
+          <a:solidFill>
+            <a:schemeClr val="tx1"/>
+          </a:solidFill>
+          <a:ln/>
+          <a:effectLst>
+            <a:outerShdw sx="100000" sy="100000" kx="0" ky="0" algn="bl" rotWithShape="0" blurRad="76200" dist="25400" dir="5400000">
+              <a:srgbClr val="1B2A2F">
+                <a:alpha val="25000"/>
+              </a:srgbClr>
+            </a:outerShdw>
+          </a:effectLst>
+        </p:spPr>
+      </p:sp>
+      <p:pic>
+        <p:nvPicPr>
+          <p:cNvPr id="26" name="Anh ht-modal" descr="Hộp thoại Điểm danh bổ sung: chọn trạng thái, nhập lý do, Xác nhận">    </p:cNvPr>
+          <p:cNvPicPr>
+            <a:picLocks noChangeAspect="1"/>
+          </p:cNvPicPr>
+          <p:nvPr/>
+        </p:nvPicPr>
+        <p:blipFill>
+          <a:blip r:embed="rId2"/>
+          <a:stretch>
+            <a:fillRect/>
+          </a:stretch>
+        </p:blipFill>
+        <p:spPr>
+          <a:xfrm>
+            <a:off x="7086600" y="1600200"/>
+            <a:ext cx="1463040" cy="1601436"/>
+          </a:xfrm>
+          <a:prstGeom prst="rect">
+            <a:avLst/>
+          </a:prstGeom>
+        </p:spPr>
+      </p:pic>
+      <p:sp>
+        <p:nvSpPr>
+          <p:cNvPr id="27" name="So 3"/>
+          <p:cNvSpPr/>
+          <p:nvPr/>
+        </p:nvSpPr>
+        <p:spPr>
+          <a:xfrm>
+            <a:off x="8677656" y="1982370"/>
+            <a:ext cx="292608" cy="292608"/>
+          </a:xfrm>
+          <a:prstGeom prst="ellipse">
+            <a:avLst/>
+          </a:prstGeom>
+          <a:solidFill>
+            <a:schemeClr val="accent2"/>
+          </a:solidFill>
+          <a:ln/>
+        </p:spPr>
+      </p:sp>
+      <p:sp>
+        <p:nvSpPr>
+          <p:cNvPr id="28" name="Text 24"/>
+          <p:cNvSpPr txBox="1"/>
+          <p:nvPr/>
+        </p:nvSpPr>
+        <p:spPr>
+          <a:xfrm>
+            <a:off x="8677656" y="1982370"/>
+            <a:ext cx="292608" cy="292608"/>
+          </a:xfrm>
+          <a:prstGeom prst="rect">
+            <a:avLst/>
+          </a:prstGeom>
+          <a:noFill/>
+          <a:ln/>
+        </p:spPr>
+        <p:txBody>
+          <a:bodyPr wrap="square" lIns="0" tIns="0" rIns="0" bIns="0" rtlCol="0" anchor="ctr"/>
+          <a:lstStyle/>
+          <a:p>
+            <a:pPr algn="ctr" indent="0" marL="0">
+              <a:buNone/>
+            </a:pPr>
+            <a:r>
+              <a:rPr lang="en-US" sz="1300" b="1" dirty="0">
+                <a:solidFill>
+                  <a:schemeClr val="bg1"/>
+                </a:solidFill>
+              </a:rPr>
+              <a:t>3</a:t>
+            </a:r>
+            <a:endParaRPr lang="en-US" sz="1300" dirty="0"/>
+          </a:p>
+        </p:txBody>
+      </p:sp>
+      <p:sp>
+        <p:nvSpPr>
+          <p:cNvPr id="29" name="So 4"/>
+          <p:cNvSpPr/>
+          <p:nvPr/>
+        </p:nvSpPr>
+        <p:spPr>
+          <a:xfrm>
+            <a:off x="8677656" y="2334686"/>
+            <a:ext cx="292608" cy="292608"/>
+          </a:xfrm>
+          <a:prstGeom prst="ellipse">
+            <a:avLst/>
+          </a:prstGeom>
+          <a:solidFill>
+            <a:schemeClr val="accent2"/>
+          </a:solidFill>
+          <a:ln/>
+        </p:spPr>
+      </p:sp>
+      <p:sp>
+        <p:nvSpPr>
+          <p:cNvPr id="30" name="Text 26"/>
+          <p:cNvSpPr txBox="1"/>
+          <p:nvPr/>
+        </p:nvSpPr>
+        <p:spPr>
+          <a:xfrm>
+            <a:off x="8677656" y="2334686"/>
+            <a:ext cx="292608" cy="292608"/>
+          </a:xfrm>
+          <a:prstGeom prst="rect">
+            <a:avLst/>
+          </a:prstGeom>
+          <a:noFill/>
+          <a:ln/>
+        </p:spPr>
+        <p:txBody>
+          <a:bodyPr wrap="square" lIns="0" tIns="0" rIns="0" bIns="0" rtlCol="0" anchor="ctr"/>
+          <a:lstStyle/>
+          <a:p>
+            <a:pPr algn="ctr" indent="0" marL="0">
+              <a:buNone/>
+            </a:pPr>
+            <a:r>
+              <a:rPr lang="en-US" sz="1300" b="1" dirty="0">
+                <a:solidFill>
+                  <a:schemeClr val="bg1"/>
+                </a:solidFill>
+              </a:rPr>
+              <a:t>4</a:t>
+            </a:r>
+            <a:endParaRPr lang="en-US" sz="1300" dirty="0"/>
+          </a:p>
+        </p:txBody>
+      </p:sp>
+      <p:sp>
+        <p:nvSpPr>
+          <p:cNvPr id="31" name="So 5"/>
+          <p:cNvSpPr/>
+          <p:nvPr/>
+        </p:nvSpPr>
+        <p:spPr>
+          <a:xfrm>
+            <a:off x="8677656" y="2895188"/>
+            <a:ext cx="292608" cy="292608"/>
+          </a:xfrm>
+          <a:prstGeom prst="ellipse">
+            <a:avLst/>
+          </a:prstGeom>
+          <a:solidFill>
+            <a:schemeClr val="accent2"/>
+          </a:solidFill>
+          <a:ln/>
+        </p:spPr>
+      </p:sp>
+      <p:sp>
+        <p:nvSpPr>
+          <p:cNvPr id="32" name="Text 28"/>
+          <p:cNvSpPr txBox="1"/>
+          <p:nvPr/>
+        </p:nvSpPr>
+        <p:spPr>
+          <a:xfrm>
+            <a:off x="8677656" y="2895188"/>
+            <a:ext cx="292608" cy="292608"/>
+          </a:xfrm>
+          <a:prstGeom prst="rect">
+            <a:avLst/>
+          </a:prstGeom>
+          <a:noFill/>
+          <a:ln/>
+        </p:spPr>
+        <p:txBody>
+          <a:bodyPr wrap="square" lIns="0" tIns="0" rIns="0" bIns="0" rtlCol="0" anchor="ctr"/>
+          <a:lstStyle/>
+          <a:p>
+            <a:pPr algn="ctr" indent="0" marL="0">
+              <a:buNone/>
+            </a:pPr>
+            <a:r>
+              <a:rPr lang="en-US" sz="1300" b="1" dirty="0">
+                <a:solidFill>
+                  <a:schemeClr val="bg1"/>
+                </a:solidFill>
+              </a:rPr>
+              <a:t>5</a:t>
+            </a:r>
+            <a:endParaRPr lang="en-US" sz="1300" dirty="0"/>
+          </a:p>
+        </p:txBody>
+      </p:sp>
+      <p:sp>
+        <p:nvSpPr>
+          <p:cNvPr id="25" name="Slide Number Placeholder 0"/>
+          <p:cNvSpPr>
+            <a:spLocks noGrp="1"/>
+          </p:cNvSpPr>
+          <p:nvPr>
+            <p:ph type="sldNum" sz="quarter" idx="4294967295"/>
+          </p:nvPr>
+        </p:nvSpPr>
+        <p:spPr>
+          <a:xfrm>
+            <a:off x="8229600" y="4754880"/>
+            <a:ext cx="457200" cy="228600"/>
+          </a:xfrm>
+          <a:prstGeom prst="rect">
+            <a:avLst/>
+          </a:prstGeom>
+          <a:extLst>
+            <a:ext uri="{C572A759-6A51-4108-AA02-DFA0A04FC94B}">
+              <ma14:wrappingTextBoxFlag xmlns:ma14="http://schemas.microsoft.com/office/mac/drawingml/2011/main" val="0"/>
+            </a:ext>
+          </a:extLst>
+        </p:spPr>
+        <p:txBody>
+          <a:bodyPr/>
+          <a:lstStyle>
+            <a:lvl1pPr>
+              <a:defRPr sz="1000">
+                <a:solidFill>
+                  <a:schemeClr val="accent5"/>
+                </a:solidFill>
+              </a:defRPr>
+            </a:lvl1pPr>
+          </a:lstStyle>
+          <a:p>
+            <a:pPr algn="r"/>
+            <a:fld id="{F7021451-1387-4CA6-816F-3879F97B5CBC}" type="slidenum">
+              <a:rPr b="0" lang="en-US"/>
+              <a:t>6</a:t>
+            </a:fld>
+            <a:endParaRPr lang="en-US"/>
+          </a:p>
+        </p:txBody>
+      </p:sp>
+    </p:spTree>
+  </p:cSld>
+  <p:clrMapOvr>
+    <a:masterClrMapping/>
+  </p:clrMapOvr>
+</p:sld>
+</file>
+
+<file path=ppt/slides/slide7.xml><?xml version="1.0" encoding="utf-8"?>
+<p:sld xmlns:a="http://schemas.openxmlformats.org/drawingml/2006/main" xmlns:r="http://schemas.openxmlformats.org/officeDocument/2006/relationships" xmlns:p="http://schemas.openxmlformats.org/presentationml/2006/main">
+  <p:cSld name="Slide 7">
+    <p:spTree>
+      <p:nvGrpSpPr>
+        <p:cNvPr id="1" name=""/>
+        <p:cNvGrpSpPr/>
+        <p:nvPr/>
+      </p:nvGrpSpPr>
+      <p:grpSpPr>
+        <a:xfrm>
+          <a:off x="0" y="0"/>
+          <a:ext cx="0" cy="0"/>
+          <a:chOff x="0" y="0"/>
+          <a:chExt cx="0" cy="0"/>
+        </a:xfrm>
+      </p:grpSpPr>
+      <p:sp>
+        <p:nvSpPr>
+          <p:cNvPr id="2" name="Text 1"/>
+          <p:cNvSpPr/>
+          <p:nvPr>
+            <p:ph idx="101" type="title" hasCustomPrompt="1"/>
+          </p:nvPr>
+        </p:nvSpPr>
+        <p:spPr>
+          <a:xfrm>
+            <a:off x="457200" y="274320"/>
+            <a:ext cx="8229600" cy="640080"/>
+          </a:xfrm>
+          <a:prstGeom prst="rect">
+            <a:avLst/>
+          </a:prstGeom>
+          <a:noFill/>
+          <a:ln/>
+        </p:spPr>
+        <p:txBody>
+          <a:bodyPr wrap="square" lIns="0" tIns="0" rIns="0" bIns="0" rtlCol="0" anchor="ctr"/>
+          <a:lstStyle/>
+          <a:p>
+            <a:pPr algn="l" indent="0" marL="0">
+              <a:buNone/>
+            </a:pPr>
+            <a:r>
+              <a:rPr lang="en-US" sz="2800" b="1" dirty="0">
+                <a:solidFill>
+                  <a:schemeClr val="tx2"/>
+                </a:solidFill>
+              </a:rPr>
+              <a:t>Sau khi ghi – kiểm tra và phản hồi</a:t>
+            </a:r>
+            <a:endParaRPr lang="en-US" sz="2800" dirty="0"/>
+          </a:p>
+        </p:txBody>
+      </p:sp>
+      <p:sp>
+        <p:nvSpPr>
+          <p:cNvPr id="3" name="Trên màn của Thầy/Cô"/>
+          <p:cNvSpPr/>
+          <p:nvPr/>
+        </p:nvSpPr>
+        <p:spPr>
+          <a:xfrm>
+            <a:off x="457200" y="1097280"/>
+            <a:ext cx="4937760" cy="1371600"/>
+          </a:xfrm>
+          <a:prstGeom prst="roundRect">
+            <a:avLst>
+              <a:gd name="adj" fmla="val 5333"/>
+            </a:avLst>
+          </a:prstGeom>
+          <a:solidFill>
+            <a:schemeClr val="bg2"/>
+          </a:solidFill>
+          <a:ln/>
+        </p:spPr>
+      </p:sp>
+      <p:sp>
+        <p:nvSpPr>
+          <p:cNvPr id="4" name="Text 2"/>
+          <p:cNvSpPr txBox="1"/>
+          <p:nvPr/>
+        </p:nvSpPr>
+        <p:spPr>
+          <a:xfrm>
+            <a:off x="594360" y="1207008"/>
+            <a:ext cx="4663440" cy="1152144"/>
+          </a:xfrm>
+          <a:prstGeom prst="rect">
+            <a:avLst/>
+          </a:prstGeom>
+          <a:noFill/>
+          <a:ln/>
+        </p:spPr>
+        <p:txBody>
+          <a:bodyPr wrap="square" lIns="0" tIns="0" rIns="0" bIns="0" rtlCol="0" anchor="t"/>
+          <a:lstStyle/>
+          <a:p>
+            <a:pPr indent="0" marL="0">
+              <a:spcAft>
+                <a:spcPts val="600"/>
+              </a:spcAft>
+              <a:buNone/>
+            </a:pPr>
+            <a:r>
+              <a:rPr lang="en-US" sz="1600" b="1" dirty="0">
+                <a:solidFill>
+                  <a:schemeClr val="tx2"/>
+                </a:solidFill>
+              </a:rPr>
+              <a:t>Trên màn của Thầy/Cô</a:t>
+            </a:r>
+            <a:endParaRPr lang="en-US" sz="1600" dirty="0"/>
+          </a:p>
+          <a:p>
+            <a:pPr marL="177800" indent="-177800">
+              <a:spcAft>
+                <a:spcPts val="400"/>
+              </a:spcAft>
+              <a:buSzPct val="100000"/>
+              <a:buChar char="•"/>
+            </a:pPr>
+            <a:r>
+              <a:rPr lang="en-US" sz="1400" dirty="0">
+                <a:solidFill>
+                  <a:schemeClr val="tx1"/>
+                </a:solidFill>
+              </a:rPr>
+              <a:t>Nhãn đổi thành “Có mặt (Thủ công)”, tổng có mặt cập nhật</a:t>
+            </a:r>
+            <a:endParaRPr lang="en-US" sz="1600" dirty="0"/>
+          </a:p>
+          <a:p>
+            <a:pPr marL="177800" indent="-177800">
+              <a:spcAft>
+                <a:spcPts val="400"/>
+              </a:spcAft>
+              <a:buSzPct val="100000"/>
+              <a:buChar char="•"/>
+            </a:pPr>
+            <a:r>
+              <a:rPr lang="en-US" sz="1400" dirty="0">
+                <a:solidFill>
+                  <a:schemeClr val="tx1"/>
+                </a:solidFill>
+              </a:rPr>
+              <a:t>Dòng “Sửa bởi … lúc … · Lý do …” để đối chiếu sau này</a:t>
+            </a:r>
+            <a:endParaRPr lang="en-US" sz="1600" dirty="0"/>
+          </a:p>
+        </p:txBody>
+      </p:sp>
+      <p:sp>
+        <p:nvSpPr>
+          <p:cNvPr id="5" name="Text 3"/>
+          <p:cNvSpPr txBox="1"/>
+          <p:nvPr/>
+        </p:nvSpPr>
+        <p:spPr>
+          <a:xfrm>
+            <a:off x="457200" y="2743200"/>
+            <a:ext cx="4937760" cy="274320"/>
+          </a:xfrm>
+          <a:prstGeom prst="rect">
+            <a:avLst/>
+          </a:prstGeom>
+          <a:noFill/>
+          <a:ln/>
+        </p:spPr>
+        <p:txBody>
+          <a:bodyPr wrap="square" lIns="0" tIns="0" rIns="0" bIns="0" rtlCol="0" anchor="ctr"/>
+          <a:lstStyle/>
+          <a:p>
+            <a:pPr indent="0" marL="0">
+              <a:buNone/>
+            </a:pPr>
+            <a:r>
+              <a:rPr lang="en-US" sz="1400" b="1" dirty="0">
+                <a:solidFill>
+                  <a:schemeClr val="tx2"/>
+                </a:solidFill>
+              </a:rPr>
+              <a:t>Học viên thấy trên trang Lớp học:</a:t>
+            </a:r>
+            <a:endParaRPr lang="en-US" sz="1400" dirty="0"/>
+          </a:p>
+        </p:txBody>
+      </p:sp>
+      <p:sp>
+        <p:nvSpPr>
+          <p:cNvPr id="6" name="Khung hv-buoi2-sau"/>
+          <p:cNvSpPr/>
+          <p:nvPr/>
+        </p:nvSpPr>
+        <p:spPr>
+          <a:xfrm>
+            <a:off x="466344" y="3118104"/>
+            <a:ext cx="2816352" cy="1003050"/>
+          </a:xfrm>
+          <a:prstGeom prst="roundRect">
+            <a:avLst>
+              <a:gd name="adj" fmla="val 5470"/>
+            </a:avLst>
+          </a:prstGeom>
+          <a:solidFill>
+            <a:schemeClr val="bg1"/>
+          </a:solidFill>
+          <a:ln w="12700">
+            <a:solidFill>
+              <a:schemeClr val="accent6"/>
+            </a:solidFill>
+            <a:prstDash val="solid"/>
+          </a:ln>
+        </p:spPr>
+      </p:sp>
+      <p:pic>
+        <p:nvPicPr>
+          <p:cNvPr id="7" name="Anh hv-buoi2-sau" descr="Học viên thấy Buổi 2 có mặt">    </p:cNvPr>
+          <p:cNvPicPr>
+            <a:picLocks noChangeAspect="1"/>
+          </p:cNvPicPr>
+          <p:nvPr/>
+        </p:nvPicPr>
+        <p:blipFill>
+          <a:blip r:embed="rId1"/>
+          <a:stretch>
+            <a:fillRect/>
+          </a:stretch>
+        </p:blipFill>
+        <p:spPr>
+          <a:xfrm>
+            <a:off x="502920" y="3154680"/>
+            <a:ext cx="2743200" cy="929898"/>
+          </a:xfrm>
+          <a:prstGeom prst="rect">
+            <a:avLst/>
+          </a:prstGeom>
+        </p:spPr>
+      </p:pic>
+      <p:sp>
+        <p:nvSpPr>
+          <p:cNvPr id="8" name="Text 5"/>
+          <p:cNvSpPr txBox="1"/>
+          <p:nvPr/>
+        </p:nvSpPr>
+        <p:spPr>
+          <a:xfrm>
+            <a:off x="3474720" y="3154680"/>
+            <a:ext cx="1920240" cy="914400"/>
+          </a:xfrm>
+          <a:prstGeom prst="rect">
+            <a:avLst/>
+          </a:prstGeom>
+          <a:noFill/>
+          <a:ln/>
+        </p:spPr>
+        <p:txBody>
+          <a:bodyPr wrap="square" lIns="0" tIns="0" rIns="0" bIns="0" rtlCol="0" anchor="t"/>
+          <a:lstStyle/>
+          <a:p>
+            <a:pPr indent="0" marL="0">
+              <a:buNone/>
+            </a:pPr>
+            <a:r>
+              <a:rPr lang="en-US" sz="1300" dirty="0">
+                <a:solidFill>
+                  <a:schemeClr val="tx1"/>
+                </a:solidFill>
+              </a:rPr>
+              <a:t>Nhắn học viên kiểm tra lại (Zalo hoặc trả lời yêu cầu hỗ trợ).</a:t>
+            </a:r>
+            <a:endParaRPr lang="en-US" sz="1300" dirty="0"/>
+          </a:p>
+        </p:txBody>
+      </p:sp>
+      <p:sp>
+        <p:nvSpPr>
+          <p:cNvPr id="9" name="Khung ht-sau-khi-ghi"/>
+          <p:cNvSpPr/>
+          <p:nvPr/>
+        </p:nvSpPr>
+        <p:spPr>
+          <a:xfrm>
+            <a:off x="6611112" y="987552"/>
+            <a:ext cx="1956816" cy="3363585"/>
+          </a:xfrm>
+          <a:prstGeom prst="roundRect">
+            <a:avLst>
+              <a:gd name="adj" fmla="val 5607"/>
+            </a:avLst>
+          </a:prstGeom>
+          <a:solidFill>
+            <a:schemeClr val="tx1"/>
+          </a:solidFill>
+          <a:ln/>
+          <a:effectLst>
+            <a:outerShdw sx="100000" sy="100000" kx="0" ky="0" algn="bl" rotWithShape="0" blurRad="76200" dist="25400" dir="5400000">
+              <a:srgbClr val="1B2A2F">
+                <a:alpha val="25000"/>
+              </a:srgbClr>
+            </a:outerShdw>
+          </a:effectLst>
+        </p:spPr>
+      </p:sp>
+      <p:pic>
+        <p:nvPicPr>
+          <p:cNvPr id="10" name="Anh ht-sau-khi-ghi" descr="Buổi 2 hiện Có mặt (Thủ công), người sửa, thời điểm và lý do">    </p:cNvPr>
+          <p:cNvPicPr>
+            <a:picLocks noChangeAspect="1"/>
+          </p:cNvPicPr>
+          <p:nvPr/>
+        </p:nvPicPr>
+        <p:blipFill>
+          <a:blip r:embed="rId2"/>
+          <a:stretch>
+            <a:fillRect/>
+          </a:stretch>
+        </p:blipFill>
+        <p:spPr>
+          <a:xfrm>
+            <a:off x="6675120" y="1051560"/>
+            <a:ext cx="1828800" cy="3235569"/>
+          </a:xfrm>
+          <a:prstGeom prst="rect">
+            <a:avLst/>
+          </a:prstGeom>
+        </p:spPr>
+      </p:pic>
+      <p:sp>
+        <p:nvSpPr>
+          <p:cNvPr id="11" name="So ✓"/>
+          <p:cNvSpPr/>
+          <p:nvPr/>
+        </p:nvSpPr>
+        <p:spPr>
+          <a:xfrm>
+            <a:off x="6254496" y="2458329"/>
+            <a:ext cx="292608" cy="292608"/>
+          </a:xfrm>
+          <a:prstGeom prst="ellipse">
+            <a:avLst/>
+          </a:prstGeom>
+          <a:solidFill>
+            <a:schemeClr val="accent2"/>
+          </a:solidFill>
+          <a:ln/>
+        </p:spPr>
+      </p:sp>
+      <p:sp>
+        <p:nvSpPr>
+          <p:cNvPr id="12" name="Text 8"/>
+          <p:cNvSpPr txBox="1"/>
+          <p:nvPr/>
+        </p:nvSpPr>
+        <p:spPr>
+          <a:xfrm>
+            <a:off x="6254496" y="2458329"/>
+            <a:ext cx="292608" cy="292608"/>
+          </a:xfrm>
+          <a:prstGeom prst="rect">
+            <a:avLst/>
+          </a:prstGeom>
+          <a:noFill/>
+          <a:ln/>
+        </p:spPr>
+        <p:txBody>
+          <a:bodyPr wrap="square" lIns="0" tIns="0" rIns="0" bIns="0" rtlCol="0" anchor="ctr"/>
+          <a:lstStyle/>
+          <a:p>
+            <a:pPr algn="ctr" indent="0" marL="0">
+              <a:buNone/>
+            </a:pPr>
+            <a:r>
+              <a:rPr lang="en-US" sz="1300" b="1" dirty="0">
+                <a:solidFill>
+                  <a:schemeClr val="bg1"/>
+                </a:solidFill>
+              </a:rPr>
+              <a:t>✓</a:t>
+            </a:r>
+            <a:endParaRPr lang="en-US" sz="1300" dirty="0"/>
+          </a:p>
+        </p:txBody>
+      </p:sp>
+      <p:sp>
+        <p:nvSpPr>
+          <p:cNvPr id="25" name="Slide Number Placeholder 0"/>
+          <p:cNvSpPr>
+            <a:spLocks noGrp="1"/>
+          </p:cNvSpPr>
+          <p:nvPr>
+            <p:ph type="sldNum" sz="quarter" idx="4294967295"/>
+          </p:nvPr>
+        </p:nvSpPr>
+        <p:spPr>
+          <a:xfrm>
+            <a:off x="8229600" y="4754880"/>
+            <a:ext cx="457200" cy="228600"/>
+          </a:xfrm>
+          <a:prstGeom prst="rect">
+            <a:avLst/>
+          </a:prstGeom>
+          <a:extLst>
+            <a:ext uri="{C572A759-6A51-4108-AA02-DFA0A04FC94B}">
+              <ma14:wrappingTextBoxFlag xmlns:ma14="http://schemas.microsoft.com/office/mac/drawingml/2011/main" val="0"/>
+            </a:ext>
+          </a:extLst>
+        </p:spPr>
+        <p:txBody>
+          <a:bodyPr/>
+          <a:lstStyle>
+            <a:lvl1pPr>
+              <a:defRPr sz="1000">
+                <a:solidFill>
+                  <a:schemeClr val="accent5"/>
+                </a:solidFill>
+              </a:defRPr>
+            </a:lvl1pPr>
+          </a:lstStyle>
+          <a:p>
+            <a:pPr algn="r"/>
+            <a:fld id="{F7021451-1387-4CA6-816F-3879F97B5CBC}" type="slidenum">
+              <a:rPr b="0" lang="en-US"/>
+              <a:t>7</a:t>
+            </a:fld>
+            <a:endParaRPr lang="en-US"/>
+          </a:p>
+        </p:txBody>
+      </p:sp>
+    </p:spTree>
+  </p:cSld>
+  <p:clrMapOvr>
+    <a:masterClrMapping/>
+  </p:clrMapOvr>
+</p:sld>
+</file>
+
+<file path=ppt/slides/slide8.xml><?xml version="1.0" encoding="utf-8"?>
+<p:sld xmlns:a="http://schemas.openxmlformats.org/drawingml/2006/main" xmlns:r="http://schemas.openxmlformats.org/officeDocument/2006/relationships" xmlns:p="http://schemas.openxmlformats.org/presentationml/2006/main">
+  <p:cSld name="Slide 8">
+    <p:spTree>
+      <p:nvGrpSpPr>
+        <p:cNvPr id="1" name=""/>
+        <p:cNvGrpSpPr/>
+        <p:nvPr/>
+      </p:nvGrpSpPr>
+      <p:grpSpPr>
+        <a:xfrm>
+          <a:off x="0" y="0"/>
+          <a:ext cx="0" cy="0"/>
+          <a:chOff x="0" y="0"/>
+          <a:chExt cx="0" cy="0"/>
+        </a:xfrm>
+      </p:grpSpPr>
+      <p:sp>
+        <p:nvSpPr>
+          <p:cNvPr id="2" name="Text 1"/>
+          <p:cNvSpPr/>
+          <p:nvPr>
+            <p:ph idx="101" type="title" hasCustomPrompt="1"/>
+          </p:nvPr>
+        </p:nvSpPr>
+        <p:spPr>
+          <a:xfrm>
+            <a:off x="457200" y="274320"/>
+            <a:ext cx="8229600" cy="640080"/>
+          </a:xfrm>
+          <a:prstGeom prst="rect">
+            <a:avLst/>
+          </a:prstGeom>
+          <a:noFill/>
+          <a:ln/>
+        </p:spPr>
+        <p:txBody>
+          <a:bodyPr wrap="square" lIns="0" tIns="0" rIns="0" bIns="0" rtlCol="0" anchor="ctr"/>
+          <a:lstStyle/>
+          <a:p>
+            <a:pPr algn="l" indent="0" marL="0">
+              <a:buNone/>
+            </a:pPr>
+            <a:r>
+              <a:rPr lang="en-US" sz="2800" b="1" dirty="0">
+                <a:solidFill>
+                  <a:schemeClr val="tx2"/>
+                </a:solidFill>
+              </a:rPr>
               <a:t>Không thấy nút hoặc bị từ chối?</a:t>
             </a:r>
             <a:endParaRPr lang="en-US" sz="2800" dirty="0"/>
@@ -5896,7 +6681,7 @@
       </p:sp>
       <p:graphicFrame>
         <p:nvGraphicFramePr>
-          <p:cNvPr id="7" name="Bang tinh huong"/>
+          <p:cNvPr id="9" name="Bang tinh huong"/>
           <p:cNvGraphicFramePr>
             <a:graphicFrameLocks noGrp="1"/>
           </p:cNvGraphicFramePr>
@@ -6419,7 +7204,7 @@
             <a:pPr algn="r"/>
             <a:fld id="{F7021451-1387-4CA6-816F-3879F97B5CBC}" type="slidenum">
               <a:rPr b="0" lang="en-US"/>
-              <a:t>6</a:t>
+              <a:t>8</a:t>
             </a:fld>
             <a:endParaRPr lang="en-US"/>
           </a:p>
@@ -6433,9 +7218,9 @@
 </p:sld>
 </file>
 
-<file path=ppt/slides/slide7.xml><?xml version="1.0" encoding="utf-8"?>
+<file path=ppt/slides/slide9.xml><?xml version="1.0" encoding="utf-8"?>
 <p:sld xmlns:a="http://schemas.openxmlformats.org/drawingml/2006/main" xmlns:r="http://schemas.openxmlformats.org/officeDocument/2006/relationships" xmlns:p="http://schemas.openxmlformats.org/presentationml/2006/main">
-  <p:cSld name="Slide 7">
+  <p:cSld name="Slide 9">
     <p:spTree>
       <p:nvGrpSpPr>
         <p:cNvPr id="1" name=""/>
@@ -6702,7 +7487,7 @@
                   <a:schemeClr val="bg1"/>
                 </a:solidFill>
               </a:rPr>
-              <a:t>Chỉ ghi khi có minh chứng</a:t>
+              <a:t>Chỉ ghi khi đã xem minh chứng</a:t>
             </a:r>
             <a:endParaRPr lang="en-US" sz="1700" dirty="0"/>
           </a:p>
@@ -6738,7 +7523,7 @@
                   <a:schemeClr val="bg2"/>
                 </a:solidFill>
               </a:rPr>
-              <a:t>Giữ ảnh/tin nhắn minh chứng trên Zalo để đối chiếu khi cần</a:t>
+              <a:t>Giữ ảnh/tin nhắn trên Zalo hoặc link trong yêu cầu hỗ trợ để đối chiếu</a:t>
             </a:r>
             <a:endParaRPr lang="en-US" sz="1400" dirty="0"/>
           </a:p>
@@ -6866,7 +7651,7 @@
                   <a:schemeClr val="bg2"/>
                 </a:solidFill>
               </a:rPr>
-              <a:t>Ghi loại minh chứng, giờ trong ảnh, ngày nhận</a:t>
+              <a:t>Ghi loại minh chứng, giờ trong ảnh, nơi nhận</a:t>
             </a:r>
             <a:endParaRPr lang="en-US" sz="1400" dirty="0"/>
           </a:p>
@@ -6994,7 +7779,7 @@
                   <a:schemeClr val="bg2"/>
                 </a:solidFill>
               </a:rPr>
-              <a:t>File Excel có họ tên – chỉ dùng nội bộ, không chuyển ra ngoài</a:t>
+              <a:t>Không tải ảnh về máy cá nhân, không chuyển tiếp; file Excel chỉ dùng nội bộ</a:t>
             </a:r>
             <a:endParaRPr lang="en-US" sz="1400" dirty="0"/>
           </a:p>

</xml_diff>